<commit_message>
Full update additional QC and Full sample design
</commit_message>
<xml_diff>
--- a/power_point/Day4.pptx
+++ b/power_point/Day4.pptx
@@ -5,10 +5,20 @@
     <p:sldMasterId id="2147483684" r:id="rId1"/>
   </p:sldMasterIdLst>
   <p:notesMasterIdLst>
-    <p:notesMasterId r:id="rId3"/>
+    <p:notesMasterId r:id="rId13"/>
   </p:notesMasterIdLst>
   <p:sldIdLst>
     <p:sldId id="256" r:id="rId2"/>
+    <p:sldId id="257" r:id="rId3"/>
+    <p:sldId id="258" r:id="rId4"/>
+    <p:sldId id="261" r:id="rId5"/>
+    <p:sldId id="262" r:id="rId6"/>
+    <p:sldId id="263" r:id="rId7"/>
+    <p:sldId id="264" r:id="rId8"/>
+    <p:sldId id="265" r:id="rId9"/>
+    <p:sldId id="266" r:id="rId10"/>
+    <p:sldId id="260" r:id="rId11"/>
+    <p:sldId id="267" r:id="rId12"/>
   </p:sldIdLst>
   <p:sldSz cx="12192000" cy="6858000"/>
   <p:notesSz cx="6858000" cy="9144000"/>
@@ -197,7 +207,7 @@
           <a:p>
             <a:fld id="{AD06BF8C-4158-F342-8216-E1A8A29CF1BB}" type="datetimeFigureOut">
               <a:rPr lang="en-GB" smtClean="0"/>
-              <a:t>13/09/2026</a:t>
+              <a:t>15/10/2026</a:t>
             </a:fld>
             <a:endParaRPr lang="en-GB"/>
           </a:p>
@@ -595,7 +605,7 @@
           <a:p>
             <a:fld id="{DE396E4B-6C64-E643-9A0A-AB5E13C2F5FA}" type="datetime1">
               <a:rPr lang="it-IT" smtClean="0"/>
-              <a:t>13/09/26</a:t>
+              <a:t>15/10/26</a:t>
             </a:fld>
             <a:endParaRPr lang="en-GB"/>
           </a:p>
@@ -768,7 +778,7 @@
           <a:p>
             <a:fld id="{31B09858-3BFB-DA41-A1A7-0A2A32E9793F}" type="datetime1">
               <a:rPr lang="it-IT" smtClean="0"/>
-              <a:t>13/09/26</a:t>
+              <a:t>15/10/26</a:t>
             </a:fld>
             <a:endParaRPr lang="en-GB"/>
           </a:p>
@@ -951,7 +961,7 @@
           <a:p>
             <a:fld id="{2C58458F-C659-9242-908F-36A06BB8B093}" type="datetime1">
               <a:rPr lang="it-IT" smtClean="0"/>
-              <a:t>13/09/26</a:t>
+              <a:t>15/10/26</a:t>
             </a:fld>
             <a:endParaRPr lang="en-GB"/>
           </a:p>
@@ -1124,7 +1134,7 @@
           <a:p>
             <a:fld id="{761DFEEA-1162-B343-ACBF-B3E92F6AC390}" type="datetime1">
               <a:rPr lang="it-IT" smtClean="0"/>
-              <a:t>13/09/26</a:t>
+              <a:t>15/10/26</a:t>
             </a:fld>
             <a:endParaRPr lang="en-GB"/>
           </a:p>
@@ -1373,7 +1383,7 @@
           <a:p>
             <a:fld id="{449ECE03-5904-2640-B404-A3FEAB598526}" type="datetime1">
               <a:rPr lang="it-IT" smtClean="0"/>
-              <a:t>13/09/26</a:t>
+              <a:t>15/10/26</a:t>
             </a:fld>
             <a:endParaRPr lang="en-GB"/>
           </a:p>
@@ -1608,7 +1618,7 @@
           <a:p>
             <a:fld id="{60BAE46A-96B1-BD4E-91A6-BD8913D3E1E1}" type="datetime1">
               <a:rPr lang="it-IT" smtClean="0"/>
-              <a:t>13/09/26</a:t>
+              <a:t>15/10/26</a:t>
             </a:fld>
             <a:endParaRPr lang="en-GB"/>
           </a:p>
@@ -1978,7 +1988,7 @@
           <a:p>
             <a:fld id="{9BACEE35-98CA-3449-A912-39DDE1219E25}" type="datetime1">
               <a:rPr lang="it-IT" smtClean="0"/>
-              <a:t>13/09/26</a:t>
+              <a:t>15/10/26</a:t>
             </a:fld>
             <a:endParaRPr lang="en-GB"/>
           </a:p>
@@ -2099,7 +2109,7 @@
           <a:p>
             <a:fld id="{5953B74D-CC1D-D544-8CB0-DB12C3D1744A}" type="datetime1">
               <a:rPr lang="it-IT" smtClean="0"/>
-              <a:t>13/09/26</a:t>
+              <a:t>15/10/26</a:t>
             </a:fld>
             <a:endParaRPr lang="en-GB"/>
           </a:p>
@@ -2197,7 +2207,7 @@
           <a:p>
             <a:fld id="{77398775-032D-C849-B9B0-C1D11ED802C1}" type="datetime1">
               <a:rPr lang="it-IT" smtClean="0"/>
-              <a:t>13/09/26</a:t>
+              <a:t>15/10/26</a:t>
             </a:fld>
             <a:endParaRPr lang="en-GB"/>
           </a:p>
@@ -2477,7 +2487,7 @@
           <a:p>
             <a:fld id="{28DD5ADB-7CE0-804E-9C85-40A519507F1A}" type="datetime1">
               <a:rPr lang="it-IT" smtClean="0"/>
-              <a:t>13/09/26</a:t>
+              <a:t>15/10/26</a:t>
             </a:fld>
             <a:endParaRPr lang="en-GB"/>
           </a:p>
@@ -2737,7 +2747,7 @@
           <a:p>
             <a:fld id="{D404C8A3-CA6B-DB4B-8A18-5294010BD3CB}" type="datetime1">
               <a:rPr lang="it-IT" smtClean="0"/>
-              <a:t>13/09/26</a:t>
+              <a:t>15/10/26</a:t>
             </a:fld>
             <a:endParaRPr lang="en-GB"/>
           </a:p>
@@ -2953,7 +2963,7 @@
           <a:p>
             <a:fld id="{01A1503F-4B7A-6348-924A-FFD23680AA8F}" type="datetime1">
               <a:rPr lang="it-IT" smtClean="0"/>
-              <a:t>13/09/26</a:t>
+              <a:t>15/10/26</a:t>
             </a:fld>
             <a:endParaRPr lang="en-GB"/>
           </a:p>
@@ -3414,7 +3424,7 @@
           <a:p>
             <a:fld id="{220AD085-7898-BE4F-A67D-B59B606A6206}" type="datetime1">
               <a:rPr lang="it-IT" smtClean="0"/>
-              <a:t>13/09/26</a:t>
+              <a:t>15/10/26</a:t>
             </a:fld>
             <a:endParaRPr lang="en-GB"/>
           </a:p>
@@ -3487,6 +3497,4341 @@
   <p:clrMapOvr>
     <a:masterClrMapping/>
   </p:clrMapOvr>
+</p:sld>
+</file>
+
+<file path=ppt/slides/slide10.xml><?xml version="1.0" encoding="utf-8"?>
+<p:sld xmlns:a="http://schemas.openxmlformats.org/drawingml/2006/main" xmlns:r="http://schemas.openxmlformats.org/officeDocument/2006/relationships" xmlns:p="http://schemas.openxmlformats.org/presentationml/2006/main">
+  <p:cSld>
+    <p:spTree>
+      <p:nvGrpSpPr>
+        <p:cNvPr id="1" name=""/>
+        <p:cNvGrpSpPr/>
+        <p:nvPr/>
+      </p:nvGrpSpPr>
+      <p:grpSpPr>
+        <a:xfrm>
+          <a:off x="0" y="0"/>
+          <a:ext cx="0" cy="0"/>
+          <a:chOff x="0" y="0"/>
+          <a:chExt cx="0" cy="0"/>
+        </a:xfrm>
+      </p:grpSpPr>
+      <p:sp>
+        <p:nvSpPr>
+          <p:cNvPr id="4" name="Date Placeholder 3">
+            <a:extLst>
+              <a:ext uri="{FF2B5EF4-FFF2-40B4-BE49-F238E27FC236}">
+                <a16:creationId xmlns:a16="http://schemas.microsoft.com/office/drawing/2014/main" id="{133ADB15-C020-BC17-A3B6-E8CB510718DC}"/>
+              </a:ext>
+            </a:extLst>
+          </p:cNvPr>
+          <p:cNvSpPr>
+            <a:spLocks noGrp="1"/>
+          </p:cNvSpPr>
+          <p:nvPr>
+            <p:ph type="dt" sz="half" idx="10"/>
+          </p:nvPr>
+        </p:nvSpPr>
+        <p:spPr/>
+        <p:txBody>
+          <a:bodyPr/>
+          <a:lstStyle/>
+          <a:p>
+            <a:fld id="{761DFEEA-1162-B343-ACBF-B3E92F6AC390}" type="datetime1">
+              <a:rPr lang="it-IT" smtClean="0"/>
+              <a:t>15/10/26</a:t>
+            </a:fld>
+            <a:endParaRPr lang="en-GB"/>
+          </a:p>
+        </p:txBody>
+      </p:sp>
+      <p:sp>
+        <p:nvSpPr>
+          <p:cNvPr id="5" name="Footer Placeholder 4">
+            <a:extLst>
+              <a:ext uri="{FF2B5EF4-FFF2-40B4-BE49-F238E27FC236}">
+                <a16:creationId xmlns:a16="http://schemas.microsoft.com/office/drawing/2014/main" id="{A5F65E55-9AEF-F759-A843-B14BC2D06ABA}"/>
+              </a:ext>
+            </a:extLst>
+          </p:cNvPr>
+          <p:cNvSpPr>
+            <a:spLocks noGrp="1"/>
+          </p:cNvSpPr>
+          <p:nvPr>
+            <p:ph type="ftr" sz="quarter" idx="11"/>
+          </p:nvPr>
+        </p:nvSpPr>
+        <p:spPr/>
+        <p:txBody>
+          <a:bodyPr/>
+          <a:lstStyle/>
+          <a:p>
+            <a:r>
+              <a:rPr lang="en-GB"/>
+              <a:t>Day 1: Reproducible NGS Data Analysis on Personal Laptops</a:t>
+            </a:r>
+          </a:p>
+        </p:txBody>
+      </p:sp>
+      <p:sp>
+        <p:nvSpPr>
+          <p:cNvPr id="6" name="Slide Number Placeholder 5">
+            <a:extLst>
+              <a:ext uri="{FF2B5EF4-FFF2-40B4-BE49-F238E27FC236}">
+                <a16:creationId xmlns:a16="http://schemas.microsoft.com/office/drawing/2014/main" id="{5727B458-9741-E7B5-024D-9720B9DEBD33}"/>
+              </a:ext>
+            </a:extLst>
+          </p:cNvPr>
+          <p:cNvSpPr>
+            <a:spLocks noGrp="1"/>
+          </p:cNvSpPr>
+          <p:nvPr>
+            <p:ph type="sldNum" sz="quarter" idx="12"/>
+          </p:nvPr>
+        </p:nvSpPr>
+        <p:spPr/>
+        <p:txBody>
+          <a:bodyPr/>
+          <a:lstStyle/>
+          <a:p>
+            <a:fld id="{62E92BA6-6E87-3343-8D2C-B7A656D628E4}" type="slidenum">
+              <a:rPr lang="en-GB" smtClean="0"/>
+              <a:t>9</a:t>
+            </a:fld>
+            <a:endParaRPr lang="en-GB"/>
+          </a:p>
+        </p:txBody>
+      </p:sp>
+    </p:spTree>
+    <p:extLst>
+      <p:ext uri="{BB962C8B-B14F-4D97-AF65-F5344CB8AC3E}">
+        <p14:creationId xmlns:p14="http://schemas.microsoft.com/office/powerpoint/2010/main" val="3166474496"/>
+      </p:ext>
+    </p:extLst>
+  </p:cSld>
+  <p:clrMapOvr>
+    <a:masterClrMapping/>
+  </p:clrMapOvr>
+</p:sld>
+</file>
+
+<file path=ppt/slides/slide11.xml><?xml version="1.0" encoding="utf-8"?>
+<p:sld xmlns:a="http://schemas.openxmlformats.org/drawingml/2006/main" xmlns:r="http://schemas.openxmlformats.org/officeDocument/2006/relationships" xmlns:p="http://schemas.openxmlformats.org/presentationml/2006/main">
+  <p:cSld>
+    <p:spTree>
+      <p:nvGrpSpPr>
+        <p:cNvPr id="1" name=""/>
+        <p:cNvGrpSpPr/>
+        <p:nvPr/>
+      </p:nvGrpSpPr>
+      <p:grpSpPr>
+        <a:xfrm>
+          <a:off x="0" y="0"/>
+          <a:ext cx="0" cy="0"/>
+          <a:chOff x="0" y="0"/>
+          <a:chExt cx="0" cy="0"/>
+        </a:xfrm>
+      </p:grpSpPr>
+      <p:sp>
+        <p:nvSpPr>
+          <p:cNvPr id="2" name="Title 1">
+            <a:extLst>
+              <a:ext uri="{FF2B5EF4-FFF2-40B4-BE49-F238E27FC236}">
+                <a16:creationId xmlns:a16="http://schemas.microsoft.com/office/drawing/2014/main" id="{49FFA50F-2CB8-CDB4-A7A0-8F9966CC65B2}"/>
+              </a:ext>
+            </a:extLst>
+          </p:cNvPr>
+          <p:cNvSpPr>
+            <a:spLocks noGrp="1"/>
+          </p:cNvSpPr>
+          <p:nvPr>
+            <p:ph type="title"/>
+          </p:nvPr>
+        </p:nvSpPr>
+        <p:spPr/>
+        <p:txBody>
+          <a:bodyPr/>
+          <a:lstStyle/>
+          <a:p>
+            <a:endParaRPr lang="en-GB"/>
+          </a:p>
+        </p:txBody>
+      </p:sp>
+      <p:sp>
+        <p:nvSpPr>
+          <p:cNvPr id="3" name="Content Placeholder 2">
+            <a:extLst>
+              <a:ext uri="{FF2B5EF4-FFF2-40B4-BE49-F238E27FC236}">
+                <a16:creationId xmlns:a16="http://schemas.microsoft.com/office/drawing/2014/main" id="{FA6C056A-4F26-EB79-B6D5-94F857F82237}"/>
+              </a:ext>
+            </a:extLst>
+          </p:cNvPr>
+          <p:cNvSpPr>
+            <a:spLocks noGrp="1"/>
+          </p:cNvSpPr>
+          <p:nvPr>
+            <p:ph idx="1"/>
+          </p:nvPr>
+        </p:nvSpPr>
+        <p:spPr/>
+        <p:txBody>
+          <a:bodyPr/>
+          <a:lstStyle/>
+          <a:p>
+            <a:endParaRPr lang="en-GB"/>
+          </a:p>
+        </p:txBody>
+      </p:sp>
+      <p:sp>
+        <p:nvSpPr>
+          <p:cNvPr id="4" name="Date Placeholder 3">
+            <a:extLst>
+              <a:ext uri="{FF2B5EF4-FFF2-40B4-BE49-F238E27FC236}">
+                <a16:creationId xmlns:a16="http://schemas.microsoft.com/office/drawing/2014/main" id="{E3065333-141C-4145-8EE7-1038D873679B}"/>
+              </a:ext>
+            </a:extLst>
+          </p:cNvPr>
+          <p:cNvSpPr>
+            <a:spLocks noGrp="1"/>
+          </p:cNvSpPr>
+          <p:nvPr>
+            <p:ph type="dt" sz="half" idx="10"/>
+          </p:nvPr>
+        </p:nvSpPr>
+        <p:spPr/>
+        <p:txBody>
+          <a:bodyPr/>
+          <a:lstStyle/>
+          <a:p>
+            <a:fld id="{761DFEEA-1162-B343-ACBF-B3E92F6AC390}" type="datetime1">
+              <a:rPr lang="it-IT" smtClean="0"/>
+              <a:t>15/10/26</a:t>
+            </a:fld>
+            <a:endParaRPr lang="en-GB"/>
+          </a:p>
+        </p:txBody>
+      </p:sp>
+      <p:sp>
+        <p:nvSpPr>
+          <p:cNvPr id="5" name="Footer Placeholder 4">
+            <a:extLst>
+              <a:ext uri="{FF2B5EF4-FFF2-40B4-BE49-F238E27FC236}">
+                <a16:creationId xmlns:a16="http://schemas.microsoft.com/office/drawing/2014/main" id="{CC9E06D8-44CA-AC86-5286-92CBB6D941B1}"/>
+              </a:ext>
+            </a:extLst>
+          </p:cNvPr>
+          <p:cNvSpPr>
+            <a:spLocks noGrp="1"/>
+          </p:cNvSpPr>
+          <p:nvPr>
+            <p:ph type="ftr" sz="quarter" idx="11"/>
+          </p:nvPr>
+        </p:nvSpPr>
+        <p:spPr/>
+        <p:txBody>
+          <a:bodyPr/>
+          <a:lstStyle/>
+          <a:p>
+            <a:r>
+              <a:rPr lang="en-GB"/>
+              <a:t>Day 1: Reproducible NGS Data Analysis on Personal Laptops</a:t>
+            </a:r>
+          </a:p>
+        </p:txBody>
+      </p:sp>
+      <p:sp>
+        <p:nvSpPr>
+          <p:cNvPr id="6" name="Slide Number Placeholder 5">
+            <a:extLst>
+              <a:ext uri="{FF2B5EF4-FFF2-40B4-BE49-F238E27FC236}">
+                <a16:creationId xmlns:a16="http://schemas.microsoft.com/office/drawing/2014/main" id="{17E6C601-5931-D44C-74C8-D15A882DF931}"/>
+              </a:ext>
+            </a:extLst>
+          </p:cNvPr>
+          <p:cNvSpPr>
+            <a:spLocks noGrp="1"/>
+          </p:cNvSpPr>
+          <p:nvPr>
+            <p:ph type="sldNum" sz="quarter" idx="12"/>
+          </p:nvPr>
+        </p:nvSpPr>
+        <p:spPr/>
+        <p:txBody>
+          <a:bodyPr/>
+          <a:lstStyle/>
+          <a:p>
+            <a:fld id="{62E92BA6-6E87-3343-8D2C-B7A656D628E4}" type="slidenum">
+              <a:rPr lang="en-GB" smtClean="0"/>
+              <a:t>10</a:t>
+            </a:fld>
+            <a:endParaRPr lang="en-GB"/>
+          </a:p>
+        </p:txBody>
+      </p:sp>
+    </p:spTree>
+    <p:extLst>
+      <p:ext uri="{BB962C8B-B14F-4D97-AF65-F5344CB8AC3E}">
+        <p14:creationId xmlns:p14="http://schemas.microsoft.com/office/powerpoint/2010/main" val="2702288332"/>
+      </p:ext>
+    </p:extLst>
+  </p:cSld>
+  <p:clrMapOvr>
+    <a:masterClrMapping/>
+  </p:clrMapOvr>
+</p:sld>
+</file>
+
+<file path=ppt/slides/slide2.xml><?xml version="1.0" encoding="utf-8"?>
+<p:sld xmlns:a="http://schemas.openxmlformats.org/drawingml/2006/main" xmlns:r="http://schemas.openxmlformats.org/officeDocument/2006/relationships" xmlns:p="http://schemas.openxmlformats.org/presentationml/2006/main">
+  <p:cSld>
+    <p:spTree>
+      <p:nvGrpSpPr>
+        <p:cNvPr id="1" name=""/>
+        <p:cNvGrpSpPr/>
+        <p:nvPr/>
+      </p:nvGrpSpPr>
+      <p:grpSpPr>
+        <a:xfrm>
+          <a:off x="0" y="0"/>
+          <a:ext cx="0" cy="0"/>
+          <a:chOff x="0" y="0"/>
+          <a:chExt cx="0" cy="0"/>
+        </a:xfrm>
+      </p:grpSpPr>
+      <p:sp>
+        <p:nvSpPr>
+          <p:cNvPr id="4" name="Date Placeholder 3">
+            <a:extLst>
+              <a:ext uri="{FF2B5EF4-FFF2-40B4-BE49-F238E27FC236}">
+                <a16:creationId xmlns:a16="http://schemas.microsoft.com/office/drawing/2014/main" id="{E82CA0C1-11B9-B3F8-24B6-20654155B521}"/>
+              </a:ext>
+            </a:extLst>
+          </p:cNvPr>
+          <p:cNvSpPr>
+            <a:spLocks noGrp="1"/>
+          </p:cNvSpPr>
+          <p:nvPr>
+            <p:ph type="dt" sz="half" idx="10"/>
+          </p:nvPr>
+        </p:nvSpPr>
+        <p:spPr/>
+        <p:txBody>
+          <a:bodyPr/>
+          <a:lstStyle/>
+          <a:p>
+            <a:fld id="{761DFEEA-1162-B343-ACBF-B3E92F6AC390}" type="datetime1">
+              <a:rPr lang="it-IT" smtClean="0"/>
+              <a:t>15/10/26</a:t>
+            </a:fld>
+            <a:endParaRPr lang="en-GB"/>
+          </a:p>
+        </p:txBody>
+      </p:sp>
+      <p:sp>
+        <p:nvSpPr>
+          <p:cNvPr id="5" name="Footer Placeholder 4">
+            <a:extLst>
+              <a:ext uri="{FF2B5EF4-FFF2-40B4-BE49-F238E27FC236}">
+                <a16:creationId xmlns:a16="http://schemas.microsoft.com/office/drawing/2014/main" id="{6E1B55DA-9B91-6FC5-42BC-62E5309282E0}"/>
+              </a:ext>
+            </a:extLst>
+          </p:cNvPr>
+          <p:cNvSpPr>
+            <a:spLocks noGrp="1"/>
+          </p:cNvSpPr>
+          <p:nvPr>
+            <p:ph type="ftr" sz="quarter" idx="11"/>
+          </p:nvPr>
+        </p:nvSpPr>
+        <p:spPr/>
+        <p:txBody>
+          <a:bodyPr/>
+          <a:lstStyle/>
+          <a:p>
+            <a:r>
+              <a:rPr lang="en-GB"/>
+              <a:t>Day 1: Reproducible NGS Data Analysis on Personal Laptops</a:t>
+            </a:r>
+          </a:p>
+        </p:txBody>
+      </p:sp>
+      <p:sp>
+        <p:nvSpPr>
+          <p:cNvPr id="6" name="Slide Number Placeholder 5">
+            <a:extLst>
+              <a:ext uri="{FF2B5EF4-FFF2-40B4-BE49-F238E27FC236}">
+                <a16:creationId xmlns:a16="http://schemas.microsoft.com/office/drawing/2014/main" id="{AC8B596A-199D-992A-6F62-A4CD7A422C75}"/>
+              </a:ext>
+            </a:extLst>
+          </p:cNvPr>
+          <p:cNvSpPr>
+            <a:spLocks noGrp="1"/>
+          </p:cNvSpPr>
+          <p:nvPr>
+            <p:ph type="sldNum" sz="quarter" idx="12"/>
+          </p:nvPr>
+        </p:nvSpPr>
+        <p:spPr/>
+        <p:txBody>
+          <a:bodyPr/>
+          <a:lstStyle/>
+          <a:p>
+            <a:fld id="{62E92BA6-6E87-3343-8D2C-B7A656D628E4}" type="slidenum">
+              <a:rPr lang="en-GB" smtClean="0"/>
+              <a:t>1</a:t>
+            </a:fld>
+            <a:endParaRPr lang="en-GB"/>
+          </a:p>
+        </p:txBody>
+      </p:sp>
+      <p:sp>
+        <p:nvSpPr>
+          <p:cNvPr id="7" name="Title 1">
+            <a:extLst>
+              <a:ext uri="{FF2B5EF4-FFF2-40B4-BE49-F238E27FC236}">
+                <a16:creationId xmlns:a16="http://schemas.microsoft.com/office/drawing/2014/main" id="{DF25E93B-7B3D-6919-4C6A-3101683DF90F}"/>
+              </a:ext>
+            </a:extLst>
+          </p:cNvPr>
+          <p:cNvSpPr txBox="1">
+            <a:spLocks/>
+          </p:cNvSpPr>
+          <p:nvPr/>
+        </p:nvSpPr>
+        <p:spPr>
+          <a:xfrm>
+            <a:off x="1524000" y="1597147"/>
+            <a:ext cx="9144000" cy="2387600"/>
+          </a:xfrm>
+          <a:prstGeom prst="rect">
+            <a:avLst/>
+          </a:prstGeom>
+        </p:spPr>
+        <p:txBody>
+          <a:bodyPr vert="horz" lIns="91440" tIns="45720" rIns="91440" bIns="45720" rtlCol="0" anchor="ctr">
+            <a:normAutofit/>
+          </a:bodyPr>
+          <a:lstStyle>
+            <a:lvl1pPr algn="l" defTabSz="914400" rtl="0" eaLnBrk="1" latinLnBrk="0" hangingPunct="1">
+              <a:lnSpc>
+                <a:spcPct val="90000"/>
+              </a:lnSpc>
+              <a:spcBef>
+                <a:spcPct val="0"/>
+              </a:spcBef>
+              <a:buNone/>
+              <a:defRPr sz="4400" kern="1200">
+                <a:solidFill>
+                  <a:schemeClr val="tx1"/>
+                </a:solidFill>
+                <a:latin typeface="+mj-lt"/>
+                <a:ea typeface="+mj-ea"/>
+                <a:cs typeface="+mj-cs"/>
+              </a:defRPr>
+            </a:lvl1pPr>
+          </a:lstStyle>
+          <a:p>
+            <a:pPr algn="ctr"/>
+            <a:r>
+              <a:rPr lang="en-IT" dirty="0"/>
+              <a:t>QC first</a:t>
+            </a:r>
+          </a:p>
+          <a:p>
+            <a:pPr algn="ctr"/>
+            <a:r>
+              <a:rPr lang="en-IT" dirty="0"/>
+              <a:t>Biological interpretation second Filtering only when justified</a:t>
+            </a:r>
+            <a:endParaRPr lang="en-GB" dirty="0"/>
+          </a:p>
+        </p:txBody>
+      </p:sp>
+    </p:spTree>
+    <p:extLst>
+      <p:ext uri="{BB962C8B-B14F-4D97-AF65-F5344CB8AC3E}">
+        <p14:creationId xmlns:p14="http://schemas.microsoft.com/office/powerpoint/2010/main" val="234426607"/>
+      </p:ext>
+    </p:extLst>
+  </p:cSld>
+  <p:clrMapOvr>
+    <a:masterClrMapping/>
+  </p:clrMapOvr>
+</p:sld>
+</file>
+
+<file path=ppt/slides/slide3.xml><?xml version="1.0" encoding="utf-8"?>
+<p:sld xmlns:a="http://schemas.openxmlformats.org/drawingml/2006/main" xmlns:r="http://schemas.openxmlformats.org/officeDocument/2006/relationships" xmlns:p="http://schemas.openxmlformats.org/presentationml/2006/main">
+  <p:cSld>
+    <p:spTree>
+      <p:nvGrpSpPr>
+        <p:cNvPr id="1" name=""/>
+        <p:cNvGrpSpPr/>
+        <p:nvPr/>
+      </p:nvGrpSpPr>
+      <p:grpSpPr>
+        <a:xfrm>
+          <a:off x="0" y="0"/>
+          <a:ext cx="0" cy="0"/>
+          <a:chOff x="0" y="0"/>
+          <a:chExt cx="0" cy="0"/>
+        </a:xfrm>
+      </p:grpSpPr>
+      <p:sp>
+        <p:nvSpPr>
+          <p:cNvPr id="2" name="Title 1">
+            <a:extLst>
+              <a:ext uri="{FF2B5EF4-FFF2-40B4-BE49-F238E27FC236}">
+                <a16:creationId xmlns:a16="http://schemas.microsoft.com/office/drawing/2014/main" id="{7AD3A1A8-77EE-4FE3-38B6-09BD4ACD4CD8}"/>
+              </a:ext>
+            </a:extLst>
+          </p:cNvPr>
+          <p:cNvSpPr>
+            <a:spLocks noGrp="1"/>
+          </p:cNvSpPr>
+          <p:nvPr>
+            <p:ph type="title"/>
+          </p:nvPr>
+        </p:nvSpPr>
+        <p:spPr/>
+        <p:txBody>
+          <a:bodyPr>
+            <a:normAutofit fontScale="90000"/>
+          </a:bodyPr>
+          <a:lstStyle/>
+          <a:p>
+            <a:r>
+              <a:rPr lang="en-IT" dirty="0"/>
+              <a:t>RNA-seq alignment QC</a:t>
+            </a:r>
+            <a:endParaRPr lang="en-GB" dirty="0"/>
+          </a:p>
+        </p:txBody>
+      </p:sp>
+      <p:sp>
+        <p:nvSpPr>
+          <p:cNvPr id="3" name="Content Placeholder 2">
+            <a:extLst>
+              <a:ext uri="{FF2B5EF4-FFF2-40B4-BE49-F238E27FC236}">
+                <a16:creationId xmlns:a16="http://schemas.microsoft.com/office/drawing/2014/main" id="{1E4775B1-3B6B-5694-00DC-E25AE10BB8AB}"/>
+              </a:ext>
+            </a:extLst>
+          </p:cNvPr>
+          <p:cNvSpPr>
+            <a:spLocks noGrp="1"/>
+          </p:cNvSpPr>
+          <p:nvPr>
+            <p:ph idx="1"/>
+          </p:nvPr>
+        </p:nvSpPr>
+        <p:spPr>
+          <a:xfrm>
+            <a:off x="388171" y="2086984"/>
+            <a:ext cx="11192435" cy="2883049"/>
+          </a:xfrm>
+        </p:spPr>
+        <p:txBody>
+          <a:bodyPr>
+            <a:normAutofit fontScale="62500" lnSpcReduction="20000"/>
+          </a:bodyPr>
+          <a:lstStyle/>
+          <a:p>
+            <a:pPr marL="0" indent="0">
+              <a:buNone/>
+            </a:pPr>
+            <a:r>
+              <a:rPr lang="en-IT" dirty="0"/>
+              <a:t>Three additional properties are particularly informative:</a:t>
+            </a:r>
+          </a:p>
+          <a:p>
+            <a:pPr marL="0" indent="0">
+              <a:buNone/>
+            </a:pPr>
+            <a:r>
+              <a:rPr lang="en-IT" b="1" dirty="0">
+                <a:solidFill>
+                  <a:schemeClr val="accent4">
+                    <a:lumMod val="75000"/>
+                  </a:schemeClr>
+                </a:solidFill>
+              </a:rPr>
+              <a:t>Duplication</a:t>
+            </a:r>
+            <a:endParaRPr lang="en-IT" dirty="0">
+              <a:solidFill>
+                <a:schemeClr val="accent4">
+                  <a:lumMod val="75000"/>
+                </a:schemeClr>
+              </a:solidFill>
+            </a:endParaRPr>
+          </a:p>
+          <a:p>
+            <a:pPr lvl="0"/>
+            <a:r>
+              <a:rPr lang="en-IT" dirty="0"/>
+              <a:t>Are many sequenced fragments represented repeatedly?</a:t>
+            </a:r>
+          </a:p>
+          <a:p>
+            <a:pPr lvl="0"/>
+            <a:r>
+              <a:rPr lang="en-IT" dirty="0"/>
+              <a:t>Is duplication explained by genuinely high transcript abundance or by low library complexity/PCR amplification?</a:t>
+            </a:r>
+          </a:p>
+          <a:p>
+            <a:pPr marL="0" indent="0">
+              <a:buNone/>
+            </a:pPr>
+            <a:r>
+              <a:rPr lang="en-IT" b="1" dirty="0">
+                <a:solidFill>
+                  <a:schemeClr val="accent4">
+                    <a:lumMod val="75000"/>
+                  </a:schemeClr>
+                </a:solidFill>
+              </a:rPr>
+              <a:t>Multi-mapping</a:t>
+            </a:r>
+            <a:endParaRPr lang="en-IT" dirty="0">
+              <a:solidFill>
+                <a:schemeClr val="accent4">
+                  <a:lumMod val="75000"/>
+                </a:schemeClr>
+              </a:solidFill>
+            </a:endParaRPr>
+          </a:p>
+          <a:p>
+            <a:pPr lvl="0"/>
+            <a:r>
+              <a:rPr lang="en-IT" dirty="0"/>
+              <a:t>Can reads be assigned confidently to one genomic position?</a:t>
+            </a:r>
+          </a:p>
+          <a:p>
+            <a:pPr lvl="0"/>
+            <a:r>
+              <a:rPr lang="en-IT" dirty="0"/>
+              <a:t>Or do several positions provide plausible alignments?</a:t>
+            </a:r>
+          </a:p>
+          <a:p>
+            <a:pPr marL="0" indent="0">
+              <a:buNone/>
+            </a:pPr>
+            <a:r>
+              <a:rPr lang="en-IT" b="1" dirty="0">
+                <a:solidFill>
+                  <a:schemeClr val="accent4">
+                    <a:lumMod val="75000"/>
+                  </a:schemeClr>
+                </a:solidFill>
+              </a:rPr>
+              <a:t>Residual rRNA</a:t>
+            </a:r>
+            <a:endParaRPr lang="en-IT" dirty="0">
+              <a:solidFill>
+                <a:schemeClr val="accent4">
+                  <a:lumMod val="75000"/>
+                </a:schemeClr>
+              </a:solidFill>
+            </a:endParaRPr>
+          </a:p>
+          <a:p>
+            <a:pPr lvl="0"/>
+            <a:r>
+              <a:rPr lang="en-IT" dirty="0"/>
+              <a:t>How much sequencing capacity was spent on ribosomal RNA rather than the RNA population of interest?</a:t>
+            </a:r>
+          </a:p>
+        </p:txBody>
+      </p:sp>
+      <p:sp>
+        <p:nvSpPr>
+          <p:cNvPr id="4" name="Date Placeholder 3">
+            <a:extLst>
+              <a:ext uri="{FF2B5EF4-FFF2-40B4-BE49-F238E27FC236}">
+                <a16:creationId xmlns:a16="http://schemas.microsoft.com/office/drawing/2014/main" id="{6DEE79F9-18D5-48D5-E265-88BA98578416}"/>
+              </a:ext>
+            </a:extLst>
+          </p:cNvPr>
+          <p:cNvSpPr>
+            <a:spLocks noGrp="1"/>
+          </p:cNvSpPr>
+          <p:nvPr>
+            <p:ph type="dt" sz="half" idx="10"/>
+          </p:nvPr>
+        </p:nvSpPr>
+        <p:spPr/>
+        <p:txBody>
+          <a:bodyPr/>
+          <a:lstStyle/>
+          <a:p>
+            <a:fld id="{761DFEEA-1162-B343-ACBF-B3E92F6AC390}" type="datetime1">
+              <a:rPr lang="it-IT" smtClean="0"/>
+              <a:t>15/10/26</a:t>
+            </a:fld>
+            <a:endParaRPr lang="en-GB"/>
+          </a:p>
+        </p:txBody>
+      </p:sp>
+      <p:sp>
+        <p:nvSpPr>
+          <p:cNvPr id="5" name="Footer Placeholder 4">
+            <a:extLst>
+              <a:ext uri="{FF2B5EF4-FFF2-40B4-BE49-F238E27FC236}">
+                <a16:creationId xmlns:a16="http://schemas.microsoft.com/office/drawing/2014/main" id="{90AFE76D-4FB2-1956-ADA2-9DA7DE2BEA3E}"/>
+              </a:ext>
+            </a:extLst>
+          </p:cNvPr>
+          <p:cNvSpPr>
+            <a:spLocks noGrp="1"/>
+          </p:cNvSpPr>
+          <p:nvPr>
+            <p:ph type="ftr" sz="quarter" idx="11"/>
+          </p:nvPr>
+        </p:nvSpPr>
+        <p:spPr/>
+        <p:txBody>
+          <a:bodyPr/>
+          <a:lstStyle/>
+          <a:p>
+            <a:r>
+              <a:rPr lang="en-GB"/>
+              <a:t>Day 1: Reproducible NGS Data Analysis on Personal Laptops</a:t>
+            </a:r>
+          </a:p>
+        </p:txBody>
+      </p:sp>
+      <p:sp>
+        <p:nvSpPr>
+          <p:cNvPr id="6" name="Slide Number Placeholder 5">
+            <a:extLst>
+              <a:ext uri="{FF2B5EF4-FFF2-40B4-BE49-F238E27FC236}">
+                <a16:creationId xmlns:a16="http://schemas.microsoft.com/office/drawing/2014/main" id="{3A38D5BD-C47B-A4CD-346C-E7C1058C00AF}"/>
+              </a:ext>
+            </a:extLst>
+          </p:cNvPr>
+          <p:cNvSpPr>
+            <a:spLocks noGrp="1"/>
+          </p:cNvSpPr>
+          <p:nvPr>
+            <p:ph type="sldNum" sz="quarter" idx="12"/>
+          </p:nvPr>
+        </p:nvSpPr>
+        <p:spPr/>
+        <p:txBody>
+          <a:bodyPr/>
+          <a:lstStyle/>
+          <a:p>
+            <a:fld id="{62E92BA6-6E87-3343-8D2C-B7A656D628E4}" type="slidenum">
+              <a:rPr lang="en-GB" smtClean="0"/>
+              <a:t>2</a:t>
+            </a:fld>
+            <a:endParaRPr lang="en-GB"/>
+          </a:p>
+        </p:txBody>
+      </p:sp>
+      <p:sp>
+        <p:nvSpPr>
+          <p:cNvPr id="8" name="TextBox 7">
+            <a:extLst>
+              <a:ext uri="{FF2B5EF4-FFF2-40B4-BE49-F238E27FC236}">
+                <a16:creationId xmlns:a16="http://schemas.microsoft.com/office/drawing/2014/main" id="{4CC6A62E-528A-80A7-853F-08AC5B8B3B32}"/>
+              </a:ext>
+            </a:extLst>
+          </p:cNvPr>
+          <p:cNvSpPr txBox="1"/>
+          <p:nvPr/>
+        </p:nvSpPr>
+        <p:spPr>
+          <a:xfrm>
+            <a:off x="231290" y="815789"/>
+            <a:ext cx="9343016" cy="954107"/>
+          </a:xfrm>
+          <a:prstGeom prst="rect">
+            <a:avLst/>
+          </a:prstGeom>
+          <a:noFill/>
+        </p:spPr>
+        <p:txBody>
+          <a:bodyPr wrap="square">
+            <a:spAutoFit/>
+          </a:bodyPr>
+          <a:lstStyle/>
+          <a:p>
+            <a:pPr marL="0" indent="0">
+              <a:buNone/>
+            </a:pPr>
+            <a:r>
+              <a:rPr lang="en-IT" sz="2800" dirty="0"/>
+              <a:t>After alignment, a high mapping rate does </a:t>
+            </a:r>
+            <a:r>
+              <a:rPr lang="en-IT" sz="2800" b="1" dirty="0"/>
+              <a:t>not</a:t>
+            </a:r>
+            <a:r>
+              <a:rPr lang="en-IT" sz="2800" dirty="0"/>
+              <a:t> guarantee a good RNA-seq library.</a:t>
+            </a:r>
+          </a:p>
+        </p:txBody>
+      </p:sp>
+      <p:sp>
+        <p:nvSpPr>
+          <p:cNvPr id="10" name="TextBox 9">
+            <a:extLst>
+              <a:ext uri="{FF2B5EF4-FFF2-40B4-BE49-F238E27FC236}">
+                <a16:creationId xmlns:a16="http://schemas.microsoft.com/office/drawing/2014/main" id="{E8411940-F594-A91E-307F-296EB3683435}"/>
+              </a:ext>
+            </a:extLst>
+          </p:cNvPr>
+          <p:cNvSpPr txBox="1"/>
+          <p:nvPr/>
+        </p:nvSpPr>
+        <p:spPr>
+          <a:xfrm>
+            <a:off x="388171" y="5026548"/>
+            <a:ext cx="10573871" cy="1015663"/>
+          </a:xfrm>
+          <a:prstGeom prst="rect">
+            <a:avLst/>
+          </a:prstGeom>
+          <a:noFill/>
+        </p:spPr>
+        <p:txBody>
+          <a:bodyPr wrap="square">
+            <a:spAutoFit/>
+          </a:bodyPr>
+          <a:lstStyle/>
+          <a:p>
+            <a:r>
+              <a:rPr lang="en-IT" sz="2000" b="1" dirty="0">
+                <a:solidFill>
+                  <a:schemeClr val="tx2">
+                    <a:lumMod val="60000"/>
+                    <a:lumOff val="40000"/>
+                  </a:schemeClr>
+                </a:solidFill>
+              </a:rPr>
+              <a:t>Key principle</a:t>
+            </a:r>
+            <a:endParaRPr lang="en-IT" sz="2000" dirty="0">
+              <a:solidFill>
+                <a:schemeClr val="tx2">
+                  <a:lumMod val="60000"/>
+                  <a:lumOff val="40000"/>
+                </a:schemeClr>
+              </a:solidFill>
+            </a:endParaRPr>
+          </a:p>
+          <a:p>
+            <a:r>
+              <a:rPr lang="en-IT" sz="2000" dirty="0"/>
+              <a:t>QC describes properties of the library. </a:t>
+            </a:r>
+          </a:p>
+          <a:p>
+            <a:r>
+              <a:rPr lang="en-IT" sz="2000" dirty="0"/>
+              <a:t>A QC signal does not automatically imply that the corresponding reads should be removed.</a:t>
+            </a:r>
+          </a:p>
+        </p:txBody>
+      </p:sp>
+    </p:spTree>
+    <p:extLst>
+      <p:ext uri="{BB962C8B-B14F-4D97-AF65-F5344CB8AC3E}">
+        <p14:creationId xmlns:p14="http://schemas.microsoft.com/office/powerpoint/2010/main" val="3822939930"/>
+      </p:ext>
+    </p:extLst>
+  </p:cSld>
+  <p:clrMapOvr>
+    <a:masterClrMapping/>
+  </p:clrMapOvr>
+</p:sld>
+</file>
+
+<file path=ppt/slides/slide4.xml><?xml version="1.0" encoding="utf-8"?>
+<p:sld xmlns:a="http://schemas.openxmlformats.org/drawingml/2006/main" xmlns:r="http://schemas.openxmlformats.org/officeDocument/2006/relationships" xmlns:p="http://schemas.openxmlformats.org/presentationml/2006/main">
+  <p:cSld>
+    <p:spTree>
+      <p:nvGrpSpPr>
+        <p:cNvPr id="1" name="">
+          <a:extLst>
+            <a:ext uri="{FF2B5EF4-FFF2-40B4-BE49-F238E27FC236}">
+              <a16:creationId xmlns:a16="http://schemas.microsoft.com/office/drawing/2014/main" id="{CCB6177A-968A-7700-D739-23C32EF77847}"/>
+            </a:ext>
+          </a:extLst>
+        </p:cNvPr>
+        <p:cNvGrpSpPr/>
+        <p:nvPr/>
+      </p:nvGrpSpPr>
+      <p:grpSpPr>
+        <a:xfrm>
+          <a:off x="0" y="0"/>
+          <a:ext cx="0" cy="0"/>
+          <a:chOff x="0" y="0"/>
+          <a:chExt cx="0" cy="0"/>
+        </a:xfrm>
+      </p:grpSpPr>
+      <p:sp>
+        <p:nvSpPr>
+          <p:cNvPr id="2" name="Title 1">
+            <a:extLst>
+              <a:ext uri="{FF2B5EF4-FFF2-40B4-BE49-F238E27FC236}">
+                <a16:creationId xmlns:a16="http://schemas.microsoft.com/office/drawing/2014/main" id="{38404E3C-1F8A-3C40-4284-4962D09D9880}"/>
+              </a:ext>
+            </a:extLst>
+          </p:cNvPr>
+          <p:cNvSpPr>
+            <a:spLocks noGrp="1"/>
+          </p:cNvSpPr>
+          <p:nvPr>
+            <p:ph type="title"/>
+          </p:nvPr>
+        </p:nvSpPr>
+        <p:spPr/>
+        <p:txBody>
+          <a:bodyPr>
+            <a:normAutofit fontScale="90000"/>
+          </a:bodyPr>
+          <a:lstStyle/>
+          <a:p>
+            <a:r>
+              <a:rPr lang="en-IT" dirty="0"/>
+              <a:t>1) Duplication: RNA-seq is not genomic DNA sequencing</a:t>
+            </a:r>
+            <a:endParaRPr lang="en-GB" dirty="0"/>
+          </a:p>
+        </p:txBody>
+      </p:sp>
+      <p:sp>
+        <p:nvSpPr>
+          <p:cNvPr id="3" name="Content Placeholder 2">
+            <a:extLst>
+              <a:ext uri="{FF2B5EF4-FFF2-40B4-BE49-F238E27FC236}">
+                <a16:creationId xmlns:a16="http://schemas.microsoft.com/office/drawing/2014/main" id="{D51A2B6D-4C24-3876-8FB9-F42A87993632}"/>
+              </a:ext>
+            </a:extLst>
+          </p:cNvPr>
+          <p:cNvSpPr>
+            <a:spLocks noGrp="1"/>
+          </p:cNvSpPr>
+          <p:nvPr>
+            <p:ph idx="1"/>
+          </p:nvPr>
+        </p:nvSpPr>
+        <p:spPr>
+          <a:xfrm>
+            <a:off x="419817" y="1389779"/>
+            <a:ext cx="11192435" cy="2547520"/>
+          </a:xfrm>
+        </p:spPr>
+        <p:txBody>
+          <a:bodyPr>
+            <a:normAutofit/>
+          </a:bodyPr>
+          <a:lstStyle/>
+          <a:p>
+            <a:pPr marL="0" indent="0">
+              <a:buNone/>
+            </a:pPr>
+            <a:r>
+              <a:rPr lang="en-IT" dirty="0"/>
+              <a:t>Possible explanations include:</a:t>
+            </a:r>
+          </a:p>
+          <a:p>
+            <a:pPr lvl="0"/>
+            <a:r>
+              <a:rPr lang="en-IT" dirty="0"/>
+              <a:t>PCR amplification of the same original molecule;</a:t>
+            </a:r>
+          </a:p>
+          <a:p>
+            <a:pPr lvl="0"/>
+            <a:r>
+              <a:rPr lang="en-IT" dirty="0"/>
+              <a:t>very abundant transcripts;</a:t>
+            </a:r>
+          </a:p>
+          <a:p>
+            <a:pPr lvl="0"/>
+            <a:r>
+              <a:rPr lang="en-IT" dirty="0"/>
+              <a:t>non-random fragmentation/start positions;</a:t>
+            </a:r>
+          </a:p>
+          <a:p>
+            <a:pPr lvl="0"/>
+            <a:r>
+              <a:rPr lang="en-IT" dirty="0"/>
+              <a:t>limited library complexity.</a:t>
+            </a:r>
+          </a:p>
+        </p:txBody>
+      </p:sp>
+      <p:sp>
+        <p:nvSpPr>
+          <p:cNvPr id="4" name="Date Placeholder 3">
+            <a:extLst>
+              <a:ext uri="{FF2B5EF4-FFF2-40B4-BE49-F238E27FC236}">
+                <a16:creationId xmlns:a16="http://schemas.microsoft.com/office/drawing/2014/main" id="{C4A8FD13-0FF1-F323-C4AA-A22B6566DB73}"/>
+              </a:ext>
+            </a:extLst>
+          </p:cNvPr>
+          <p:cNvSpPr>
+            <a:spLocks noGrp="1"/>
+          </p:cNvSpPr>
+          <p:nvPr>
+            <p:ph type="dt" sz="half" idx="10"/>
+          </p:nvPr>
+        </p:nvSpPr>
+        <p:spPr/>
+        <p:txBody>
+          <a:bodyPr/>
+          <a:lstStyle/>
+          <a:p>
+            <a:fld id="{761DFEEA-1162-B343-ACBF-B3E92F6AC390}" type="datetime1">
+              <a:rPr lang="it-IT" smtClean="0"/>
+              <a:t>15/10/26</a:t>
+            </a:fld>
+            <a:endParaRPr lang="en-GB"/>
+          </a:p>
+        </p:txBody>
+      </p:sp>
+      <p:sp>
+        <p:nvSpPr>
+          <p:cNvPr id="5" name="Footer Placeholder 4">
+            <a:extLst>
+              <a:ext uri="{FF2B5EF4-FFF2-40B4-BE49-F238E27FC236}">
+                <a16:creationId xmlns:a16="http://schemas.microsoft.com/office/drawing/2014/main" id="{52E5F186-B6AB-56FB-0704-A94CE31EFB94}"/>
+              </a:ext>
+            </a:extLst>
+          </p:cNvPr>
+          <p:cNvSpPr>
+            <a:spLocks noGrp="1"/>
+          </p:cNvSpPr>
+          <p:nvPr>
+            <p:ph type="ftr" sz="quarter" idx="11"/>
+          </p:nvPr>
+        </p:nvSpPr>
+        <p:spPr/>
+        <p:txBody>
+          <a:bodyPr/>
+          <a:lstStyle/>
+          <a:p>
+            <a:r>
+              <a:rPr lang="en-GB"/>
+              <a:t>Day 1: Reproducible NGS Data Analysis on Personal Laptops</a:t>
+            </a:r>
+          </a:p>
+        </p:txBody>
+      </p:sp>
+      <p:sp>
+        <p:nvSpPr>
+          <p:cNvPr id="6" name="Slide Number Placeholder 5">
+            <a:extLst>
+              <a:ext uri="{FF2B5EF4-FFF2-40B4-BE49-F238E27FC236}">
+                <a16:creationId xmlns:a16="http://schemas.microsoft.com/office/drawing/2014/main" id="{E913B7EF-470B-C17A-BD00-7AAFFF99E417}"/>
+              </a:ext>
+            </a:extLst>
+          </p:cNvPr>
+          <p:cNvSpPr>
+            <a:spLocks noGrp="1"/>
+          </p:cNvSpPr>
+          <p:nvPr>
+            <p:ph type="sldNum" sz="quarter" idx="12"/>
+          </p:nvPr>
+        </p:nvSpPr>
+        <p:spPr/>
+        <p:txBody>
+          <a:bodyPr/>
+          <a:lstStyle/>
+          <a:p>
+            <a:fld id="{62E92BA6-6E87-3343-8D2C-B7A656D628E4}" type="slidenum">
+              <a:rPr lang="en-GB" smtClean="0"/>
+              <a:t>3</a:t>
+            </a:fld>
+            <a:endParaRPr lang="en-GB"/>
+          </a:p>
+        </p:txBody>
+      </p:sp>
+      <p:sp>
+        <p:nvSpPr>
+          <p:cNvPr id="8" name="TextBox 7">
+            <a:extLst>
+              <a:ext uri="{FF2B5EF4-FFF2-40B4-BE49-F238E27FC236}">
+                <a16:creationId xmlns:a16="http://schemas.microsoft.com/office/drawing/2014/main" id="{3B936C53-FFD0-4AF7-C48F-EFD94D56EF4F}"/>
+              </a:ext>
+            </a:extLst>
+          </p:cNvPr>
+          <p:cNvSpPr txBox="1"/>
+          <p:nvPr/>
+        </p:nvSpPr>
+        <p:spPr>
+          <a:xfrm>
+            <a:off x="134470" y="815789"/>
+            <a:ext cx="11763488" cy="400110"/>
+          </a:xfrm>
+          <a:prstGeom prst="rect">
+            <a:avLst/>
+          </a:prstGeom>
+          <a:noFill/>
+        </p:spPr>
+        <p:txBody>
+          <a:bodyPr wrap="square">
+            <a:spAutoFit/>
+          </a:bodyPr>
+          <a:lstStyle/>
+          <a:p>
+            <a:r>
+              <a:rPr lang="en-IT" sz="2000" dirty="0"/>
+              <a:t>Two reads with identical genomic coordinates are </a:t>
+            </a:r>
+            <a:r>
+              <a:rPr lang="en-IT" sz="2000" b="1" dirty="0"/>
+              <a:t>coordinate duplicates</a:t>
+            </a:r>
+            <a:r>
+              <a:rPr lang="en-IT" sz="2000" dirty="0"/>
+              <a:t>.</a:t>
+            </a:r>
+            <a:endParaRPr lang="en-GB" sz="2000" dirty="0"/>
+          </a:p>
+        </p:txBody>
+      </p:sp>
+      <p:sp>
+        <p:nvSpPr>
+          <p:cNvPr id="11" name="TextBox 10">
+            <a:extLst>
+              <a:ext uri="{FF2B5EF4-FFF2-40B4-BE49-F238E27FC236}">
+                <a16:creationId xmlns:a16="http://schemas.microsoft.com/office/drawing/2014/main" id="{77EFAFB1-5832-82EF-540C-878515D3B879}"/>
+              </a:ext>
+            </a:extLst>
+          </p:cNvPr>
+          <p:cNvSpPr txBox="1"/>
+          <p:nvPr/>
+        </p:nvSpPr>
+        <p:spPr>
+          <a:xfrm>
+            <a:off x="419817" y="4031736"/>
+            <a:ext cx="11352366" cy="1200329"/>
+          </a:xfrm>
+          <a:prstGeom prst="rect">
+            <a:avLst/>
+          </a:prstGeom>
+          <a:noFill/>
+        </p:spPr>
+        <p:txBody>
+          <a:bodyPr wrap="square">
+            <a:spAutoFit/>
+          </a:bodyPr>
+          <a:lstStyle/>
+          <a:p>
+            <a:pPr marL="0" indent="0">
+              <a:buNone/>
+            </a:pPr>
+            <a:r>
+              <a:rPr lang="en-IT" sz="2400" dirty="0"/>
+              <a:t>In RNA-seq, highly expressed genes naturally produce many reads from a limited genomic interval. Therefore:</a:t>
+            </a:r>
+          </a:p>
+          <a:p>
+            <a:r>
+              <a:rPr lang="en-IT" sz="2400" b="1" dirty="0"/>
+              <a:t>Coordinate duplication ≠ PCR duplication.</a:t>
+            </a:r>
+            <a:endParaRPr lang="en-GB" sz="2400" dirty="0"/>
+          </a:p>
+        </p:txBody>
+      </p:sp>
+      <p:sp>
+        <p:nvSpPr>
+          <p:cNvPr id="13" name="TextBox 12">
+            <a:extLst>
+              <a:ext uri="{FF2B5EF4-FFF2-40B4-BE49-F238E27FC236}">
+                <a16:creationId xmlns:a16="http://schemas.microsoft.com/office/drawing/2014/main" id="{6FBF77C3-3B82-83C8-B38E-26B6B8255942}"/>
+              </a:ext>
+            </a:extLst>
+          </p:cNvPr>
+          <p:cNvSpPr txBox="1"/>
+          <p:nvPr/>
+        </p:nvSpPr>
+        <p:spPr>
+          <a:xfrm>
+            <a:off x="419817" y="5326502"/>
+            <a:ext cx="11352366" cy="830997"/>
+          </a:xfrm>
+          <a:prstGeom prst="rect">
+            <a:avLst/>
+          </a:prstGeom>
+          <a:noFill/>
+        </p:spPr>
+        <p:txBody>
+          <a:bodyPr wrap="square">
+            <a:spAutoFit/>
+          </a:bodyPr>
+          <a:lstStyle/>
+          <a:p>
+            <a:pPr marL="0" indent="0">
+              <a:buNone/>
+            </a:pPr>
+            <a:r>
+              <a:rPr lang="en-IT" sz="2400" dirty="0"/>
+              <a:t>Without </a:t>
+            </a:r>
+            <a:r>
+              <a:rPr lang="en-IT" sz="2400" b="1" dirty="0"/>
+              <a:t>UMIs</a:t>
+            </a:r>
+            <a:r>
+              <a:rPr lang="en-IT" sz="2400" dirty="0"/>
+              <a:t>, we usually cannot determine whether two reads at identical coordinates originated from the same original RNA molecule.</a:t>
+            </a:r>
+          </a:p>
+        </p:txBody>
+      </p:sp>
+    </p:spTree>
+    <p:extLst>
+      <p:ext uri="{BB962C8B-B14F-4D97-AF65-F5344CB8AC3E}">
+        <p14:creationId xmlns:p14="http://schemas.microsoft.com/office/powerpoint/2010/main" val="4102991689"/>
+      </p:ext>
+    </p:extLst>
+  </p:cSld>
+  <p:clrMapOvr>
+    <a:masterClrMapping/>
+  </p:clrMapOvr>
+  <p:timing>
+    <p:tnLst>
+      <p:par>
+        <p:cTn id="1" dur="indefinite" restart="never" nodeType="tmRoot">
+          <p:childTnLst>
+            <p:seq concurrent="1" nextAc="seek">
+              <p:cTn id="2" dur="indefinite" nodeType="mainSeq">
+                <p:childTnLst>
+                  <p:par>
+                    <p:cTn id="3" fill="hold">
+                      <p:stCondLst>
+                        <p:cond delay="indefinite"/>
+                      </p:stCondLst>
+                      <p:childTnLst>
+                        <p:par>
+                          <p:cTn id="4" fill="hold">
+                            <p:stCondLst>
+                              <p:cond delay="0"/>
+                            </p:stCondLst>
+                            <p:childTnLst>
+                              <p:par>
+                                <p:cTn id="5" presetID="1" presetClass="entr" presetSubtype="0" fill="hold" grpId="0" nodeType="clickEffect">
+                                  <p:stCondLst>
+                                    <p:cond delay="0"/>
+                                  </p:stCondLst>
+                                  <p:childTnLst>
+                                    <p:set>
+                                      <p:cBhvr>
+                                        <p:cTn id="6" dur="1" fill="hold">
+                                          <p:stCondLst>
+                                            <p:cond delay="0"/>
+                                          </p:stCondLst>
+                                        </p:cTn>
+                                        <p:tgtEl>
+                                          <p:spTgt spid="11"/>
+                                        </p:tgtEl>
+                                        <p:attrNameLst>
+                                          <p:attrName>style.visibility</p:attrName>
+                                        </p:attrNameLst>
+                                      </p:cBhvr>
+                                      <p:to>
+                                        <p:strVal val="visible"/>
+                                      </p:to>
+                                    </p:set>
+                                  </p:childTnLst>
+                                </p:cTn>
+                              </p:par>
+                            </p:childTnLst>
+                          </p:cTn>
+                        </p:par>
+                      </p:childTnLst>
+                    </p:cTn>
+                  </p:par>
+                  <p:par>
+                    <p:cTn id="7" fill="hold">
+                      <p:stCondLst>
+                        <p:cond delay="indefinite"/>
+                      </p:stCondLst>
+                      <p:childTnLst>
+                        <p:par>
+                          <p:cTn id="8" fill="hold">
+                            <p:stCondLst>
+                              <p:cond delay="0"/>
+                            </p:stCondLst>
+                            <p:childTnLst>
+                              <p:par>
+                                <p:cTn id="9" presetID="1" presetClass="entr" presetSubtype="0" fill="hold" grpId="0" nodeType="clickEffect">
+                                  <p:stCondLst>
+                                    <p:cond delay="0"/>
+                                  </p:stCondLst>
+                                  <p:childTnLst>
+                                    <p:set>
+                                      <p:cBhvr>
+                                        <p:cTn id="10" dur="1" fill="hold">
+                                          <p:stCondLst>
+                                            <p:cond delay="0"/>
+                                          </p:stCondLst>
+                                        </p:cTn>
+                                        <p:tgtEl>
+                                          <p:spTgt spid="13"/>
+                                        </p:tgtEl>
+                                        <p:attrNameLst>
+                                          <p:attrName>style.visibility</p:attrName>
+                                        </p:attrNameLst>
+                                      </p:cBhvr>
+                                      <p:to>
+                                        <p:strVal val="visible"/>
+                                      </p:to>
+                                    </p:set>
+                                  </p:childTnLst>
+                                </p:cTn>
+                              </p:par>
+                            </p:childTnLst>
+                          </p:cTn>
+                        </p:par>
+                      </p:childTnLst>
+                    </p:cTn>
+                  </p:par>
+                </p:childTnLst>
+              </p:cTn>
+              <p:prevCondLst>
+                <p:cond evt="onPrev" delay="0">
+                  <p:tgtEl>
+                    <p:sldTgt/>
+                  </p:tgtEl>
+                </p:cond>
+              </p:prevCondLst>
+              <p:nextCondLst>
+                <p:cond evt="onNext" delay="0">
+                  <p:tgtEl>
+                    <p:sldTgt/>
+                  </p:tgtEl>
+                </p:cond>
+              </p:nextCondLst>
+            </p:seq>
+          </p:childTnLst>
+        </p:cTn>
+      </p:par>
+    </p:tnLst>
+    <p:bldLst>
+      <p:bldP spid="11" grpId="0"/>
+      <p:bldP spid="13" grpId="0"/>
+    </p:bldLst>
+  </p:timing>
+</p:sld>
+</file>
+
+<file path=ppt/slides/slide5.xml><?xml version="1.0" encoding="utf-8"?>
+<p:sld xmlns:a="http://schemas.openxmlformats.org/drawingml/2006/main" xmlns:r="http://schemas.openxmlformats.org/officeDocument/2006/relationships" xmlns:p="http://schemas.openxmlformats.org/presentationml/2006/main">
+  <p:cSld>
+    <p:spTree>
+      <p:nvGrpSpPr>
+        <p:cNvPr id="1" name="">
+          <a:extLst>
+            <a:ext uri="{FF2B5EF4-FFF2-40B4-BE49-F238E27FC236}">
+              <a16:creationId xmlns:a16="http://schemas.microsoft.com/office/drawing/2014/main" id="{FB5EF7B8-2A5B-834E-7AC2-ADF1A44940B5}"/>
+            </a:ext>
+          </a:extLst>
+        </p:cNvPr>
+        <p:cNvGrpSpPr/>
+        <p:nvPr/>
+      </p:nvGrpSpPr>
+      <p:grpSpPr>
+        <a:xfrm>
+          <a:off x="0" y="0"/>
+          <a:ext cx="0" cy="0"/>
+          <a:chOff x="0" y="0"/>
+          <a:chExt cx="0" cy="0"/>
+        </a:xfrm>
+      </p:grpSpPr>
+      <p:sp>
+        <p:nvSpPr>
+          <p:cNvPr id="2" name="Title 1">
+            <a:extLst>
+              <a:ext uri="{FF2B5EF4-FFF2-40B4-BE49-F238E27FC236}">
+                <a16:creationId xmlns:a16="http://schemas.microsoft.com/office/drawing/2014/main" id="{BF27BE7F-C0DF-224D-BE66-BA68B3F820C0}"/>
+              </a:ext>
+            </a:extLst>
+          </p:cNvPr>
+          <p:cNvSpPr>
+            <a:spLocks noGrp="1"/>
+          </p:cNvSpPr>
+          <p:nvPr>
+            <p:ph type="title"/>
+          </p:nvPr>
+        </p:nvSpPr>
+        <p:spPr/>
+        <p:txBody>
+          <a:bodyPr>
+            <a:normAutofit fontScale="90000"/>
+          </a:bodyPr>
+          <a:lstStyle/>
+          <a:p>
+            <a:r>
+              <a:rPr lang="en-IT" dirty="0"/>
+              <a:t>1) Duplication: RNA-seq is not genomic DNA sequencing</a:t>
+            </a:r>
+            <a:endParaRPr lang="en-GB" dirty="0"/>
+          </a:p>
+        </p:txBody>
+      </p:sp>
+      <p:sp>
+        <p:nvSpPr>
+          <p:cNvPr id="4" name="Date Placeholder 3">
+            <a:extLst>
+              <a:ext uri="{FF2B5EF4-FFF2-40B4-BE49-F238E27FC236}">
+                <a16:creationId xmlns:a16="http://schemas.microsoft.com/office/drawing/2014/main" id="{01FDA4B1-0C86-3E63-C5C8-50AC66CE6DC6}"/>
+              </a:ext>
+            </a:extLst>
+          </p:cNvPr>
+          <p:cNvSpPr>
+            <a:spLocks noGrp="1"/>
+          </p:cNvSpPr>
+          <p:nvPr>
+            <p:ph type="dt" sz="half" idx="10"/>
+          </p:nvPr>
+        </p:nvSpPr>
+        <p:spPr/>
+        <p:txBody>
+          <a:bodyPr/>
+          <a:lstStyle/>
+          <a:p>
+            <a:fld id="{761DFEEA-1162-B343-ACBF-B3E92F6AC390}" type="datetime1">
+              <a:rPr lang="it-IT" smtClean="0"/>
+              <a:t>15/10/26</a:t>
+            </a:fld>
+            <a:endParaRPr lang="en-GB"/>
+          </a:p>
+        </p:txBody>
+      </p:sp>
+      <p:sp>
+        <p:nvSpPr>
+          <p:cNvPr id="5" name="Footer Placeholder 4">
+            <a:extLst>
+              <a:ext uri="{FF2B5EF4-FFF2-40B4-BE49-F238E27FC236}">
+                <a16:creationId xmlns:a16="http://schemas.microsoft.com/office/drawing/2014/main" id="{05C97BC3-F99E-E0C3-D6AD-9BD0390F70D2}"/>
+              </a:ext>
+            </a:extLst>
+          </p:cNvPr>
+          <p:cNvSpPr>
+            <a:spLocks noGrp="1"/>
+          </p:cNvSpPr>
+          <p:nvPr>
+            <p:ph type="ftr" sz="quarter" idx="11"/>
+          </p:nvPr>
+        </p:nvSpPr>
+        <p:spPr/>
+        <p:txBody>
+          <a:bodyPr/>
+          <a:lstStyle/>
+          <a:p>
+            <a:r>
+              <a:rPr lang="en-GB"/>
+              <a:t>Day 1: Reproducible NGS Data Analysis on Personal Laptops</a:t>
+            </a:r>
+          </a:p>
+        </p:txBody>
+      </p:sp>
+      <p:sp>
+        <p:nvSpPr>
+          <p:cNvPr id="6" name="Slide Number Placeholder 5">
+            <a:extLst>
+              <a:ext uri="{FF2B5EF4-FFF2-40B4-BE49-F238E27FC236}">
+                <a16:creationId xmlns:a16="http://schemas.microsoft.com/office/drawing/2014/main" id="{9A95AE75-0D9B-EE1D-DE48-668587D4447B}"/>
+              </a:ext>
+            </a:extLst>
+          </p:cNvPr>
+          <p:cNvSpPr>
+            <a:spLocks noGrp="1"/>
+          </p:cNvSpPr>
+          <p:nvPr>
+            <p:ph type="sldNum" sz="quarter" idx="12"/>
+          </p:nvPr>
+        </p:nvSpPr>
+        <p:spPr/>
+        <p:txBody>
+          <a:bodyPr/>
+          <a:lstStyle/>
+          <a:p>
+            <a:fld id="{62E92BA6-6E87-3343-8D2C-B7A656D628E4}" type="slidenum">
+              <a:rPr lang="en-GB" smtClean="0"/>
+              <a:t>4</a:t>
+            </a:fld>
+            <a:endParaRPr lang="en-GB"/>
+          </a:p>
+        </p:txBody>
+      </p:sp>
+      <p:sp>
+        <p:nvSpPr>
+          <p:cNvPr id="9" name="TextBox 8">
+            <a:extLst>
+              <a:ext uri="{FF2B5EF4-FFF2-40B4-BE49-F238E27FC236}">
+                <a16:creationId xmlns:a16="http://schemas.microsoft.com/office/drawing/2014/main" id="{E99E06D9-DD5A-3926-49A5-1107A8BFC8C2}"/>
+              </a:ext>
+            </a:extLst>
+          </p:cNvPr>
+          <p:cNvSpPr txBox="1"/>
+          <p:nvPr/>
+        </p:nvSpPr>
+        <p:spPr>
+          <a:xfrm>
+            <a:off x="385571" y="1674672"/>
+            <a:ext cx="5195323" cy="646331"/>
+          </a:xfrm>
+          <a:prstGeom prst="rect">
+            <a:avLst/>
+          </a:prstGeom>
+          <a:noFill/>
+        </p:spPr>
+        <p:txBody>
+          <a:bodyPr wrap="square">
+            <a:spAutoFit/>
+          </a:bodyPr>
+          <a:lstStyle/>
+          <a:p>
+            <a:r>
+              <a:rPr lang="en-IT" b="1" dirty="0">
+                <a:solidFill>
+                  <a:schemeClr val="accent4">
+                    <a:lumMod val="75000"/>
+                  </a:schemeClr>
+                </a:solidFill>
+              </a:rPr>
+              <a:t>dupRadar</a:t>
+            </a:r>
+            <a:r>
+              <a:rPr lang="en-IT" dirty="0"/>
+              <a:t> asks a better RNA-seq-specific question:</a:t>
+            </a:r>
+          </a:p>
+          <a:p>
+            <a:r>
+              <a:rPr lang="en-IT" dirty="0"/>
+              <a:t>Does duplication increase with gene expression?</a:t>
+            </a:r>
+          </a:p>
+        </p:txBody>
+      </p:sp>
+      <p:sp>
+        <p:nvSpPr>
+          <p:cNvPr id="13" name="TextBox 12">
+            <a:extLst>
+              <a:ext uri="{FF2B5EF4-FFF2-40B4-BE49-F238E27FC236}">
+                <a16:creationId xmlns:a16="http://schemas.microsoft.com/office/drawing/2014/main" id="{2C2C4215-8291-5ABC-887D-06B3ADAAD4B9}"/>
+              </a:ext>
+            </a:extLst>
+          </p:cNvPr>
+          <p:cNvSpPr txBox="1"/>
+          <p:nvPr/>
+        </p:nvSpPr>
+        <p:spPr>
+          <a:xfrm>
+            <a:off x="385571" y="927458"/>
+            <a:ext cx="11420855" cy="461665"/>
+          </a:xfrm>
+          <a:prstGeom prst="rect">
+            <a:avLst/>
+          </a:prstGeom>
+          <a:noFill/>
+        </p:spPr>
+        <p:txBody>
+          <a:bodyPr wrap="square">
+            <a:spAutoFit/>
+          </a:bodyPr>
+          <a:lstStyle/>
+          <a:p>
+            <a:pPr marL="0" indent="0">
+              <a:buNone/>
+            </a:pPr>
+            <a:r>
+              <a:rPr lang="en-IT" sz="2400" dirty="0"/>
+              <a:t>A global duplicate percentage is useful, but it lacks biological context.</a:t>
+            </a:r>
+          </a:p>
+        </p:txBody>
+      </p:sp>
+      <p:sp>
+        <p:nvSpPr>
+          <p:cNvPr id="15" name="TextBox 14">
+            <a:extLst>
+              <a:ext uri="{FF2B5EF4-FFF2-40B4-BE49-F238E27FC236}">
+                <a16:creationId xmlns:a16="http://schemas.microsoft.com/office/drawing/2014/main" id="{883AA451-68EE-DEB0-F380-4BB45D111910}"/>
+              </a:ext>
+            </a:extLst>
+          </p:cNvPr>
+          <p:cNvSpPr txBox="1"/>
+          <p:nvPr/>
+        </p:nvSpPr>
+        <p:spPr>
+          <a:xfrm>
+            <a:off x="385572" y="2606552"/>
+            <a:ext cx="5144790" cy="1754326"/>
+          </a:xfrm>
+          <a:prstGeom prst="rect">
+            <a:avLst/>
+          </a:prstGeom>
+          <a:noFill/>
+        </p:spPr>
+        <p:txBody>
+          <a:bodyPr wrap="square">
+            <a:spAutoFit/>
+          </a:bodyPr>
+          <a:lstStyle/>
+          <a:p>
+            <a:r>
+              <a:rPr lang="en-IT" sz="1800" b="1" dirty="0">
+                <a:solidFill>
+                  <a:schemeClr val="accent4">
+                    <a:lumMod val="75000"/>
+                  </a:schemeClr>
+                </a:solidFill>
+              </a:rPr>
+              <a:t>Expected:</a:t>
+            </a:r>
+          </a:p>
+          <a:p>
+            <a:pPr lvl="0"/>
+            <a:r>
+              <a:rPr lang="en-IT" sz="1800" dirty="0"/>
+              <a:t>higher duplication among highly expressed genes.</a:t>
+            </a:r>
+          </a:p>
+          <a:p>
+            <a:pPr lvl="0"/>
+            <a:endParaRPr lang="en-IT" sz="1800" dirty="0"/>
+          </a:p>
+          <a:p>
+            <a:r>
+              <a:rPr lang="en-IT" sz="1800" b="1" dirty="0">
+                <a:solidFill>
+                  <a:schemeClr val="accent4">
+                    <a:lumMod val="75000"/>
+                  </a:schemeClr>
+                </a:solidFill>
+              </a:rPr>
+              <a:t>More concerning:</a:t>
+            </a:r>
+          </a:p>
+          <a:p>
+            <a:pPr lvl="0"/>
+            <a:r>
+              <a:rPr lang="en-IT" sz="1800" dirty="0"/>
+              <a:t>high duplication extending across low-expression genes; replicates behaving differently from the others.</a:t>
+            </a:r>
+          </a:p>
+        </p:txBody>
+      </p:sp>
+      <p:sp>
+        <p:nvSpPr>
+          <p:cNvPr id="17" name="TextBox 16">
+            <a:extLst>
+              <a:ext uri="{FF2B5EF4-FFF2-40B4-BE49-F238E27FC236}">
+                <a16:creationId xmlns:a16="http://schemas.microsoft.com/office/drawing/2014/main" id="{0E03B613-6B5E-4C63-EB68-FC1E1295AC7E}"/>
+              </a:ext>
+            </a:extLst>
+          </p:cNvPr>
+          <p:cNvSpPr txBox="1"/>
+          <p:nvPr/>
+        </p:nvSpPr>
+        <p:spPr>
+          <a:xfrm>
+            <a:off x="385571" y="4824305"/>
+            <a:ext cx="11608688" cy="1200329"/>
+          </a:xfrm>
+          <a:prstGeom prst="rect">
+            <a:avLst/>
+          </a:prstGeom>
+          <a:noFill/>
+        </p:spPr>
+        <p:txBody>
+          <a:bodyPr wrap="square">
+            <a:spAutoFit/>
+          </a:bodyPr>
+          <a:lstStyle/>
+          <a:p>
+            <a:r>
+              <a:rPr lang="en-IT" sz="1800" b="1" dirty="0"/>
+              <a:t>Good practice</a:t>
+            </a:r>
+            <a:endParaRPr lang="en-IT" sz="1800" dirty="0"/>
+          </a:p>
+          <a:p>
+            <a:r>
+              <a:rPr lang="en-IT" sz="1800" dirty="0"/>
+              <a:t>Measure and report duplication, compare replicates and inspect its relationship with expression.</a:t>
+            </a:r>
+          </a:p>
+          <a:p>
+            <a:r>
+              <a:rPr lang="en-IT" sz="1800" b="1" dirty="0"/>
+              <a:t>Do not routinely deduplicate standard RNA-seq BAMs.</a:t>
+            </a:r>
+            <a:endParaRPr lang="en-IT" sz="1800" dirty="0"/>
+          </a:p>
+          <a:p>
+            <a:r>
+              <a:rPr lang="en-IT" sz="1800" dirty="0"/>
+              <a:t>Removing coordinate duplicates can systematically remove legitimate reads from highly expressed genes.</a:t>
+            </a:r>
+          </a:p>
+        </p:txBody>
+      </p:sp>
+      <p:pic>
+        <p:nvPicPr>
+          <p:cNvPr id="18" name="Picture 17" descr="Using the dupRadar package • dupRadar">
+            <a:extLst>
+              <a:ext uri="{FF2B5EF4-FFF2-40B4-BE49-F238E27FC236}">
+                <a16:creationId xmlns:a16="http://schemas.microsoft.com/office/drawing/2014/main" id="{572EB7D3-83B1-E261-6D55-A07DB8401EC6}"/>
+              </a:ext>
+            </a:extLst>
+          </p:cNvPr>
+          <p:cNvPicPr>
+            <a:picLocks noChangeAspect="1"/>
+          </p:cNvPicPr>
+          <p:nvPr/>
+        </p:nvPicPr>
+        <p:blipFill>
+          <a:blip r:embed="rId2"/>
+          <a:stretch>
+            <a:fillRect/>
+          </a:stretch>
+        </p:blipFill>
+        <p:spPr>
+          <a:xfrm>
+            <a:off x="5580894" y="1674672"/>
+            <a:ext cx="6225532" cy="3112766"/>
+          </a:xfrm>
+          <a:prstGeom prst="rect">
+            <a:avLst/>
+          </a:prstGeom>
+        </p:spPr>
+      </p:pic>
+    </p:spTree>
+    <p:extLst>
+      <p:ext uri="{BB962C8B-B14F-4D97-AF65-F5344CB8AC3E}">
+        <p14:creationId xmlns:p14="http://schemas.microsoft.com/office/powerpoint/2010/main" val="876892888"/>
+      </p:ext>
+    </p:extLst>
+  </p:cSld>
+  <p:clrMapOvr>
+    <a:masterClrMapping/>
+  </p:clrMapOvr>
+  <p:timing>
+    <p:tnLst>
+      <p:par>
+        <p:cTn id="1" dur="indefinite" restart="never" nodeType="tmRoot">
+          <p:childTnLst>
+            <p:seq concurrent="1" nextAc="seek">
+              <p:cTn id="2" dur="indefinite" nodeType="mainSeq">
+                <p:childTnLst>
+                  <p:par>
+                    <p:cTn id="3" fill="hold">
+                      <p:stCondLst>
+                        <p:cond delay="indefinite"/>
+                      </p:stCondLst>
+                      <p:childTnLst>
+                        <p:par>
+                          <p:cTn id="4" fill="hold">
+                            <p:stCondLst>
+                              <p:cond delay="0"/>
+                            </p:stCondLst>
+                            <p:childTnLst>
+                              <p:par>
+                                <p:cTn id="5" presetID="1" presetClass="entr" presetSubtype="0" fill="hold" grpId="0" nodeType="clickEffect">
+                                  <p:stCondLst>
+                                    <p:cond delay="0"/>
+                                  </p:stCondLst>
+                                  <p:childTnLst>
+                                    <p:set>
+                                      <p:cBhvr>
+                                        <p:cTn id="6" dur="1" fill="hold">
+                                          <p:stCondLst>
+                                            <p:cond delay="0"/>
+                                          </p:stCondLst>
+                                        </p:cTn>
+                                        <p:tgtEl>
+                                          <p:spTgt spid="9"/>
+                                        </p:tgtEl>
+                                        <p:attrNameLst>
+                                          <p:attrName>style.visibility</p:attrName>
+                                        </p:attrNameLst>
+                                      </p:cBhvr>
+                                      <p:to>
+                                        <p:strVal val="visible"/>
+                                      </p:to>
+                                    </p:set>
+                                  </p:childTnLst>
+                                </p:cTn>
+                              </p:par>
+                            </p:childTnLst>
+                          </p:cTn>
+                        </p:par>
+                      </p:childTnLst>
+                    </p:cTn>
+                  </p:par>
+                  <p:par>
+                    <p:cTn id="7" fill="hold">
+                      <p:stCondLst>
+                        <p:cond delay="indefinite"/>
+                      </p:stCondLst>
+                      <p:childTnLst>
+                        <p:par>
+                          <p:cTn id="8" fill="hold">
+                            <p:stCondLst>
+                              <p:cond delay="0"/>
+                            </p:stCondLst>
+                            <p:childTnLst>
+                              <p:par>
+                                <p:cTn id="9" presetID="1" presetClass="entr" presetSubtype="0" fill="hold" grpId="0" nodeType="clickEffect">
+                                  <p:stCondLst>
+                                    <p:cond delay="0"/>
+                                  </p:stCondLst>
+                                  <p:childTnLst>
+                                    <p:set>
+                                      <p:cBhvr>
+                                        <p:cTn id="10" dur="1" fill="hold">
+                                          <p:stCondLst>
+                                            <p:cond delay="0"/>
+                                          </p:stCondLst>
+                                        </p:cTn>
+                                        <p:tgtEl>
+                                          <p:spTgt spid="15"/>
+                                        </p:tgtEl>
+                                        <p:attrNameLst>
+                                          <p:attrName>style.visibility</p:attrName>
+                                        </p:attrNameLst>
+                                      </p:cBhvr>
+                                      <p:to>
+                                        <p:strVal val="visible"/>
+                                      </p:to>
+                                    </p:set>
+                                  </p:childTnLst>
+                                </p:cTn>
+                              </p:par>
+                            </p:childTnLst>
+                          </p:cTn>
+                        </p:par>
+                      </p:childTnLst>
+                    </p:cTn>
+                  </p:par>
+                  <p:par>
+                    <p:cTn id="11" fill="hold">
+                      <p:stCondLst>
+                        <p:cond delay="indefinite"/>
+                      </p:stCondLst>
+                      <p:childTnLst>
+                        <p:par>
+                          <p:cTn id="12" fill="hold">
+                            <p:stCondLst>
+                              <p:cond delay="0"/>
+                            </p:stCondLst>
+                            <p:childTnLst>
+                              <p:par>
+                                <p:cTn id="13" presetID="1" presetClass="entr" presetSubtype="0" fill="hold" nodeType="clickEffect">
+                                  <p:stCondLst>
+                                    <p:cond delay="0"/>
+                                  </p:stCondLst>
+                                  <p:childTnLst>
+                                    <p:set>
+                                      <p:cBhvr>
+                                        <p:cTn id="14" dur="1" fill="hold">
+                                          <p:stCondLst>
+                                            <p:cond delay="0"/>
+                                          </p:stCondLst>
+                                        </p:cTn>
+                                        <p:tgtEl>
+                                          <p:spTgt spid="18"/>
+                                        </p:tgtEl>
+                                        <p:attrNameLst>
+                                          <p:attrName>style.visibility</p:attrName>
+                                        </p:attrNameLst>
+                                      </p:cBhvr>
+                                      <p:to>
+                                        <p:strVal val="visible"/>
+                                      </p:to>
+                                    </p:set>
+                                  </p:childTnLst>
+                                </p:cTn>
+                              </p:par>
+                            </p:childTnLst>
+                          </p:cTn>
+                        </p:par>
+                      </p:childTnLst>
+                    </p:cTn>
+                  </p:par>
+                  <p:par>
+                    <p:cTn id="15" fill="hold">
+                      <p:stCondLst>
+                        <p:cond delay="indefinite"/>
+                      </p:stCondLst>
+                      <p:childTnLst>
+                        <p:par>
+                          <p:cTn id="16" fill="hold">
+                            <p:stCondLst>
+                              <p:cond delay="0"/>
+                            </p:stCondLst>
+                            <p:childTnLst>
+                              <p:par>
+                                <p:cTn id="17" presetID="1" presetClass="entr" presetSubtype="0" fill="hold" grpId="0" nodeType="clickEffect">
+                                  <p:stCondLst>
+                                    <p:cond delay="0"/>
+                                  </p:stCondLst>
+                                  <p:childTnLst>
+                                    <p:set>
+                                      <p:cBhvr>
+                                        <p:cTn id="18" dur="1" fill="hold">
+                                          <p:stCondLst>
+                                            <p:cond delay="0"/>
+                                          </p:stCondLst>
+                                        </p:cTn>
+                                        <p:tgtEl>
+                                          <p:spTgt spid="17"/>
+                                        </p:tgtEl>
+                                        <p:attrNameLst>
+                                          <p:attrName>style.visibility</p:attrName>
+                                        </p:attrNameLst>
+                                      </p:cBhvr>
+                                      <p:to>
+                                        <p:strVal val="visible"/>
+                                      </p:to>
+                                    </p:set>
+                                  </p:childTnLst>
+                                </p:cTn>
+                              </p:par>
+                            </p:childTnLst>
+                          </p:cTn>
+                        </p:par>
+                      </p:childTnLst>
+                    </p:cTn>
+                  </p:par>
+                </p:childTnLst>
+              </p:cTn>
+              <p:prevCondLst>
+                <p:cond evt="onPrev" delay="0">
+                  <p:tgtEl>
+                    <p:sldTgt/>
+                  </p:tgtEl>
+                </p:cond>
+              </p:prevCondLst>
+              <p:nextCondLst>
+                <p:cond evt="onNext" delay="0">
+                  <p:tgtEl>
+                    <p:sldTgt/>
+                  </p:tgtEl>
+                </p:cond>
+              </p:nextCondLst>
+            </p:seq>
+          </p:childTnLst>
+        </p:cTn>
+      </p:par>
+    </p:tnLst>
+    <p:bldLst>
+      <p:bldP spid="9" grpId="0"/>
+      <p:bldP spid="15" grpId="0"/>
+      <p:bldP spid="17" grpId="0"/>
+    </p:bldLst>
+  </p:timing>
+</p:sld>
+</file>
+
+<file path=ppt/slides/slide6.xml><?xml version="1.0" encoding="utf-8"?>
+<p:sld xmlns:a="http://schemas.openxmlformats.org/drawingml/2006/main" xmlns:r="http://schemas.openxmlformats.org/officeDocument/2006/relationships" xmlns:p="http://schemas.openxmlformats.org/presentationml/2006/main">
+  <p:cSld>
+    <p:spTree>
+      <p:nvGrpSpPr>
+        <p:cNvPr id="1" name=""/>
+        <p:cNvGrpSpPr/>
+        <p:nvPr/>
+      </p:nvGrpSpPr>
+      <p:grpSpPr>
+        <a:xfrm>
+          <a:off x="0" y="0"/>
+          <a:ext cx="0" cy="0"/>
+          <a:chOff x="0" y="0"/>
+          <a:chExt cx="0" cy="0"/>
+        </a:xfrm>
+      </p:grpSpPr>
+      <p:sp>
+        <p:nvSpPr>
+          <p:cNvPr id="2" name="Title 1">
+            <a:extLst>
+              <a:ext uri="{FF2B5EF4-FFF2-40B4-BE49-F238E27FC236}">
+                <a16:creationId xmlns:a16="http://schemas.microsoft.com/office/drawing/2014/main" id="{8FC17FAE-82CF-F224-5198-73C7A7927E0D}"/>
+              </a:ext>
+            </a:extLst>
+          </p:cNvPr>
+          <p:cNvSpPr>
+            <a:spLocks noGrp="1"/>
+          </p:cNvSpPr>
+          <p:nvPr>
+            <p:ph type="title"/>
+          </p:nvPr>
+        </p:nvSpPr>
+        <p:spPr/>
+        <p:txBody>
+          <a:bodyPr>
+            <a:normAutofit fontScale="90000"/>
+          </a:bodyPr>
+          <a:lstStyle/>
+          <a:p>
+            <a:r>
+              <a:rPr lang="en-IT" dirty="0"/>
+              <a:t>2) Multi-mapping: ambiguity is not binary</a:t>
+            </a:r>
+            <a:endParaRPr lang="en-GB" dirty="0"/>
+          </a:p>
+        </p:txBody>
+      </p:sp>
+      <p:sp>
+        <p:nvSpPr>
+          <p:cNvPr id="4" name="Date Placeholder 3">
+            <a:extLst>
+              <a:ext uri="{FF2B5EF4-FFF2-40B4-BE49-F238E27FC236}">
+                <a16:creationId xmlns:a16="http://schemas.microsoft.com/office/drawing/2014/main" id="{1928259C-7FC2-AB76-9D70-F6C6B5E7337E}"/>
+              </a:ext>
+            </a:extLst>
+          </p:cNvPr>
+          <p:cNvSpPr>
+            <a:spLocks noGrp="1"/>
+          </p:cNvSpPr>
+          <p:nvPr>
+            <p:ph type="dt" sz="half" idx="10"/>
+          </p:nvPr>
+        </p:nvSpPr>
+        <p:spPr/>
+        <p:txBody>
+          <a:bodyPr/>
+          <a:lstStyle/>
+          <a:p>
+            <a:fld id="{761DFEEA-1162-B343-ACBF-B3E92F6AC390}" type="datetime1">
+              <a:rPr lang="it-IT" smtClean="0"/>
+              <a:t>15/10/26</a:t>
+            </a:fld>
+            <a:endParaRPr lang="en-GB"/>
+          </a:p>
+        </p:txBody>
+      </p:sp>
+      <p:sp>
+        <p:nvSpPr>
+          <p:cNvPr id="5" name="Footer Placeholder 4">
+            <a:extLst>
+              <a:ext uri="{FF2B5EF4-FFF2-40B4-BE49-F238E27FC236}">
+                <a16:creationId xmlns:a16="http://schemas.microsoft.com/office/drawing/2014/main" id="{BB77C0C7-059C-8CB0-1D40-A012857A9829}"/>
+              </a:ext>
+            </a:extLst>
+          </p:cNvPr>
+          <p:cNvSpPr>
+            <a:spLocks noGrp="1"/>
+          </p:cNvSpPr>
+          <p:nvPr>
+            <p:ph type="ftr" sz="quarter" idx="11"/>
+          </p:nvPr>
+        </p:nvSpPr>
+        <p:spPr/>
+        <p:txBody>
+          <a:bodyPr/>
+          <a:lstStyle/>
+          <a:p>
+            <a:r>
+              <a:rPr lang="en-GB"/>
+              <a:t>Day 1: Reproducible NGS Data Analysis on Personal Laptops</a:t>
+            </a:r>
+          </a:p>
+        </p:txBody>
+      </p:sp>
+      <p:sp>
+        <p:nvSpPr>
+          <p:cNvPr id="6" name="Slide Number Placeholder 5">
+            <a:extLst>
+              <a:ext uri="{FF2B5EF4-FFF2-40B4-BE49-F238E27FC236}">
+                <a16:creationId xmlns:a16="http://schemas.microsoft.com/office/drawing/2014/main" id="{9A68F805-F323-607E-947A-AE3BAC55D187}"/>
+              </a:ext>
+            </a:extLst>
+          </p:cNvPr>
+          <p:cNvSpPr>
+            <a:spLocks noGrp="1"/>
+          </p:cNvSpPr>
+          <p:nvPr>
+            <p:ph type="sldNum" sz="quarter" idx="12"/>
+          </p:nvPr>
+        </p:nvSpPr>
+        <p:spPr/>
+        <p:txBody>
+          <a:bodyPr/>
+          <a:lstStyle/>
+          <a:p>
+            <a:fld id="{62E92BA6-6E87-3343-8D2C-B7A656D628E4}" type="slidenum">
+              <a:rPr lang="en-GB" smtClean="0"/>
+              <a:t>5</a:t>
+            </a:fld>
+            <a:endParaRPr lang="en-GB"/>
+          </a:p>
+        </p:txBody>
+      </p:sp>
+      <p:sp>
+        <p:nvSpPr>
+          <p:cNvPr id="8" name="TextBox 7">
+            <a:extLst>
+              <a:ext uri="{FF2B5EF4-FFF2-40B4-BE49-F238E27FC236}">
+                <a16:creationId xmlns:a16="http://schemas.microsoft.com/office/drawing/2014/main" id="{042B4370-0A8A-455B-CBCF-01FA45709DEA}"/>
+              </a:ext>
+            </a:extLst>
+          </p:cNvPr>
+          <p:cNvSpPr txBox="1"/>
+          <p:nvPr/>
+        </p:nvSpPr>
+        <p:spPr>
+          <a:xfrm>
+            <a:off x="1184425" y="1393348"/>
+            <a:ext cx="1751134" cy="923330"/>
+          </a:xfrm>
+          <a:prstGeom prst="rect">
+            <a:avLst/>
+          </a:prstGeom>
+          <a:noFill/>
+          <a:ln>
+            <a:solidFill>
+              <a:schemeClr val="tx1"/>
+            </a:solidFill>
+          </a:ln>
+        </p:spPr>
+        <p:txBody>
+          <a:bodyPr wrap="square">
+            <a:spAutoFit/>
+          </a:bodyPr>
+          <a:lstStyle/>
+          <a:p>
+            <a:r>
+              <a:rPr lang="en-GB" dirty="0"/>
+              <a:t>one position</a:t>
+            </a:r>
+          </a:p>
+          <a:p>
+            <a:r>
+              <a:rPr lang="en-GB" dirty="0"/>
+              <a:t>      ↓</a:t>
+            </a:r>
+          </a:p>
+          <a:p>
+            <a:r>
+              <a:rPr lang="en-GB" dirty="0"/>
+              <a:t>high confidence</a:t>
+            </a:r>
+          </a:p>
+        </p:txBody>
+      </p:sp>
+      <p:sp>
+        <p:nvSpPr>
+          <p:cNvPr id="9" name="TextBox 8">
+            <a:extLst>
+              <a:ext uri="{FF2B5EF4-FFF2-40B4-BE49-F238E27FC236}">
+                <a16:creationId xmlns:a16="http://schemas.microsoft.com/office/drawing/2014/main" id="{6270EE68-2D3A-BA20-8799-63025814DAF4}"/>
+              </a:ext>
+            </a:extLst>
+          </p:cNvPr>
+          <p:cNvSpPr txBox="1"/>
+          <p:nvPr/>
+        </p:nvSpPr>
+        <p:spPr>
+          <a:xfrm>
+            <a:off x="1184425" y="832962"/>
+            <a:ext cx="2367315" cy="369332"/>
+          </a:xfrm>
+          <a:prstGeom prst="rect">
+            <a:avLst/>
+          </a:prstGeom>
+          <a:noFill/>
+        </p:spPr>
+        <p:txBody>
+          <a:bodyPr wrap="none" rtlCol="0">
+            <a:spAutoFit/>
+          </a:bodyPr>
+          <a:lstStyle/>
+          <a:p>
+            <a:r>
+              <a:rPr lang="en-GB" b="1" dirty="0">
+                <a:solidFill>
+                  <a:schemeClr val="accent4">
+                    <a:lumMod val="75000"/>
+                  </a:schemeClr>
+                </a:solidFill>
+              </a:rPr>
+              <a:t>Reads could map to:</a:t>
+            </a:r>
+          </a:p>
+        </p:txBody>
+      </p:sp>
+      <p:sp>
+        <p:nvSpPr>
+          <p:cNvPr id="11" name="TextBox 10">
+            <a:extLst>
+              <a:ext uri="{FF2B5EF4-FFF2-40B4-BE49-F238E27FC236}">
+                <a16:creationId xmlns:a16="http://schemas.microsoft.com/office/drawing/2014/main" id="{58B7241A-0981-6617-4E23-740B6542F8BC}"/>
+              </a:ext>
+            </a:extLst>
+          </p:cNvPr>
+          <p:cNvSpPr txBox="1"/>
+          <p:nvPr/>
+        </p:nvSpPr>
+        <p:spPr>
+          <a:xfrm>
+            <a:off x="3076236" y="1393348"/>
+            <a:ext cx="3941152" cy="923330"/>
+          </a:xfrm>
+          <a:prstGeom prst="rect">
+            <a:avLst/>
+          </a:prstGeom>
+          <a:noFill/>
+          <a:ln>
+            <a:solidFill>
+              <a:schemeClr val="tx1"/>
+            </a:solidFill>
+          </a:ln>
+        </p:spPr>
+        <p:txBody>
+          <a:bodyPr wrap="square">
+            <a:spAutoFit/>
+          </a:bodyPr>
+          <a:lstStyle/>
+          <a:p>
+            <a:r>
+              <a:rPr lang="en-GB" sz="1800" dirty="0"/>
+              <a:t>several positions, but one clearly better</a:t>
+            </a:r>
+          </a:p>
+          <a:p>
+            <a:r>
+              <a:rPr lang="en-GB" sz="1800" dirty="0"/>
+              <a:t>      ↓</a:t>
+            </a:r>
+          </a:p>
+          <a:p>
+            <a:r>
+              <a:rPr lang="en-GB" sz="1800" dirty="0"/>
+              <a:t>intermediate/high confidence</a:t>
+            </a:r>
+          </a:p>
+        </p:txBody>
+      </p:sp>
+      <p:sp>
+        <p:nvSpPr>
+          <p:cNvPr id="13" name="TextBox 12">
+            <a:extLst>
+              <a:ext uri="{FF2B5EF4-FFF2-40B4-BE49-F238E27FC236}">
+                <a16:creationId xmlns:a16="http://schemas.microsoft.com/office/drawing/2014/main" id="{11FE02F4-7130-9EBB-E980-FCE2D4203964}"/>
+              </a:ext>
+            </a:extLst>
+          </p:cNvPr>
+          <p:cNvSpPr txBox="1"/>
+          <p:nvPr/>
+        </p:nvSpPr>
+        <p:spPr>
+          <a:xfrm>
+            <a:off x="7158065" y="1393348"/>
+            <a:ext cx="3593121" cy="923330"/>
+          </a:xfrm>
+          <a:prstGeom prst="rect">
+            <a:avLst/>
+          </a:prstGeom>
+          <a:noFill/>
+          <a:ln>
+            <a:solidFill>
+              <a:schemeClr val="tx1"/>
+            </a:solidFill>
+          </a:ln>
+        </p:spPr>
+        <p:txBody>
+          <a:bodyPr wrap="square">
+            <a:spAutoFit/>
+          </a:bodyPr>
+          <a:lstStyle/>
+          <a:p>
+            <a:r>
+              <a:rPr lang="en-GB" sz="1800" dirty="0"/>
+              <a:t>several equally plausible positions</a:t>
+            </a:r>
+          </a:p>
+          <a:p>
+            <a:r>
+              <a:rPr lang="en-GB" sz="1800" dirty="0"/>
+              <a:t>      ↓</a:t>
+            </a:r>
+          </a:p>
+          <a:p>
+            <a:r>
+              <a:rPr lang="en-GB" sz="1800" dirty="0"/>
+              <a:t>low confidence</a:t>
+            </a:r>
+          </a:p>
+        </p:txBody>
+      </p:sp>
+      <p:sp>
+        <p:nvSpPr>
+          <p:cNvPr id="15" name="TextBox 14">
+            <a:extLst>
+              <a:ext uri="{FF2B5EF4-FFF2-40B4-BE49-F238E27FC236}">
+                <a16:creationId xmlns:a16="http://schemas.microsoft.com/office/drawing/2014/main" id="{2580B64A-8A37-B335-FFDE-41148D86A42D}"/>
+              </a:ext>
+            </a:extLst>
+          </p:cNvPr>
+          <p:cNvSpPr txBox="1"/>
+          <p:nvPr/>
+        </p:nvSpPr>
+        <p:spPr>
+          <a:xfrm>
+            <a:off x="134470" y="2595237"/>
+            <a:ext cx="7426175" cy="369332"/>
+          </a:xfrm>
+          <a:prstGeom prst="rect">
+            <a:avLst/>
+          </a:prstGeom>
+          <a:noFill/>
+        </p:spPr>
+        <p:txBody>
+          <a:bodyPr wrap="square">
+            <a:spAutoFit/>
+          </a:bodyPr>
+          <a:lstStyle/>
+          <a:p>
+            <a:r>
+              <a:rPr lang="en-IT" b="1" dirty="0">
+                <a:solidFill>
+                  <a:schemeClr val="accent4">
+                    <a:lumMod val="75000"/>
+                  </a:schemeClr>
+                </a:solidFill>
+              </a:rPr>
+              <a:t>How confident is the aligner in the reported genomic placement?</a:t>
+            </a:r>
+            <a:endParaRPr lang="en-GB" b="1" dirty="0">
+              <a:solidFill>
+                <a:schemeClr val="accent4">
+                  <a:lumMod val="75000"/>
+                </a:schemeClr>
+              </a:solidFill>
+            </a:endParaRPr>
+          </a:p>
+        </p:txBody>
+      </p:sp>
+      <p:sp>
+        <p:nvSpPr>
+          <p:cNvPr id="17" name="TextBox 16">
+            <a:extLst>
+              <a:ext uri="{FF2B5EF4-FFF2-40B4-BE49-F238E27FC236}">
+                <a16:creationId xmlns:a16="http://schemas.microsoft.com/office/drawing/2014/main" id="{0C5D0313-4715-B434-361E-214C40867695}"/>
+              </a:ext>
+            </a:extLst>
+          </p:cNvPr>
+          <p:cNvSpPr txBox="1"/>
+          <p:nvPr/>
+        </p:nvSpPr>
+        <p:spPr>
+          <a:xfrm>
+            <a:off x="134470" y="2998415"/>
+            <a:ext cx="7023595" cy="1384995"/>
+          </a:xfrm>
+          <a:prstGeom prst="rect">
+            <a:avLst/>
+          </a:prstGeom>
+          <a:noFill/>
+        </p:spPr>
+        <p:txBody>
+          <a:bodyPr wrap="square">
+            <a:spAutoFit/>
+          </a:bodyPr>
+          <a:lstStyle/>
+          <a:p>
+            <a:pPr>
+              <a:buNone/>
+            </a:pPr>
+            <a:r>
+              <a:rPr lang="en-IT" sz="1400" dirty="0"/>
+              <a:t>Aligners combine alignment scores, alternative placements and other information into </a:t>
+            </a:r>
+            <a:r>
+              <a:rPr lang="en-IT" sz="1400" b="1" dirty="0"/>
+              <a:t>MAPQ</a:t>
+            </a:r>
+            <a:r>
+              <a:rPr lang="en-IT" sz="1400" dirty="0"/>
+              <a:t>.</a:t>
+            </a:r>
+          </a:p>
+          <a:p>
+            <a:pPr>
+              <a:buNone/>
+            </a:pPr>
+            <a:r>
+              <a:rPr lang="en-IT" sz="1400" dirty="0"/>
+              <a:t>For Bowtie2:</a:t>
+            </a:r>
+          </a:p>
+          <a:p>
+            <a:pPr marL="342900" lvl="0" indent="-342900">
+              <a:buFont typeface="Arial" panose="020B0604020202020204" pitchFamily="34" charset="0"/>
+              <a:buChar char="•"/>
+            </a:pPr>
+            <a:r>
+              <a:rPr lang="en-IT" sz="1400" dirty="0">
+                <a:latin typeface="+mn-lt"/>
+              </a:rPr>
+              <a:t>AS</a:t>
+            </a:r>
+            <a:r>
+              <a:rPr lang="en-IT" sz="1400" dirty="0"/>
+              <a:t> = score of the reported alignment;</a:t>
+            </a:r>
+          </a:p>
+          <a:p>
+            <a:pPr marL="342900" lvl="0" indent="-342900">
+              <a:buFont typeface="Arial" panose="020B0604020202020204" pitchFamily="34" charset="0"/>
+              <a:buChar char="•"/>
+            </a:pPr>
+            <a:r>
+              <a:rPr lang="en-IT" sz="1400" dirty="0">
+                <a:latin typeface="+mn-lt"/>
+              </a:rPr>
+              <a:t>XS</a:t>
+            </a:r>
+            <a:r>
+              <a:rPr lang="en-IT" sz="1400" dirty="0"/>
+              <a:t> = score of the best alternative alignment found;</a:t>
+            </a:r>
+          </a:p>
+          <a:p>
+            <a:pPr marL="342900" lvl="0" indent="-342900">
+              <a:buFont typeface="Arial" panose="020B0604020202020204" pitchFamily="34" charset="0"/>
+              <a:buChar char="•"/>
+            </a:pPr>
+            <a:r>
+              <a:rPr lang="en-IT" sz="1400" dirty="0"/>
+              <a:t>similar </a:t>
+            </a:r>
+            <a:r>
+              <a:rPr lang="en-IT" sz="1400" dirty="0">
+                <a:latin typeface="+mn-lt"/>
+              </a:rPr>
+              <a:t>AS</a:t>
+            </a:r>
+            <a:r>
+              <a:rPr lang="en-IT" sz="1400" dirty="0"/>
+              <a:t> and </a:t>
+            </a:r>
+            <a:r>
+              <a:rPr lang="en-IT" sz="1400" dirty="0">
+                <a:latin typeface="+mn-lt"/>
+              </a:rPr>
+              <a:t>XS</a:t>
+            </a:r>
+            <a:r>
+              <a:rPr lang="en-IT" sz="1400" dirty="0"/>
+              <a:t> → greater ambiguity;</a:t>
+            </a:r>
+          </a:p>
+          <a:p>
+            <a:pPr marL="342900" lvl="0" indent="-342900">
+              <a:buFont typeface="Arial" panose="020B0604020202020204" pitchFamily="34" charset="0"/>
+              <a:buChar char="•"/>
+            </a:pPr>
+            <a:r>
+              <a:rPr lang="en-IT" sz="1400" dirty="0"/>
+              <a:t>MAPQ summarizes confidence in the selected placement.</a:t>
+            </a:r>
+          </a:p>
+        </p:txBody>
+      </p:sp>
+      <p:sp>
+        <p:nvSpPr>
+          <p:cNvPr id="19" name="TextBox 18">
+            <a:extLst>
+              <a:ext uri="{FF2B5EF4-FFF2-40B4-BE49-F238E27FC236}">
+                <a16:creationId xmlns:a16="http://schemas.microsoft.com/office/drawing/2014/main" id="{7EB13354-C821-2803-8DA4-C3C4654044D0}"/>
+              </a:ext>
+            </a:extLst>
+          </p:cNvPr>
+          <p:cNvSpPr txBox="1"/>
+          <p:nvPr/>
+        </p:nvSpPr>
+        <p:spPr>
+          <a:xfrm>
+            <a:off x="134470" y="4510545"/>
+            <a:ext cx="7023594" cy="954107"/>
+          </a:xfrm>
+          <a:prstGeom prst="rect">
+            <a:avLst/>
+          </a:prstGeom>
+          <a:noFill/>
+        </p:spPr>
+        <p:txBody>
+          <a:bodyPr wrap="square">
+            <a:spAutoFit/>
+          </a:bodyPr>
+          <a:lstStyle/>
+          <a:p>
+            <a:pPr>
+              <a:buNone/>
+            </a:pPr>
+            <a:r>
+              <a:rPr lang="en-IT" sz="1400" b="1" dirty="0">
+                <a:solidFill>
+                  <a:schemeClr val="accent4">
+                    <a:lumMod val="75000"/>
+                  </a:schemeClr>
+                </a:solidFill>
+              </a:rPr>
+              <a:t>Important:</a:t>
+            </a:r>
+          </a:p>
+          <a:p>
+            <a:pPr>
+              <a:buNone/>
+            </a:pPr>
+            <a:r>
+              <a:rPr lang="en-IT" sz="1400" b="1" dirty="0"/>
+              <a:t>SAM FLAG </a:t>
+            </a:r>
+            <a:r>
+              <a:rPr lang="en-IT" sz="1400" b="1" dirty="0">
+                <a:latin typeface="+mn-lt"/>
+              </a:rPr>
+              <a:t>0x100</a:t>
+            </a:r>
+            <a:r>
+              <a:rPr lang="en-IT" sz="1400" b="1" dirty="0"/>
+              <a:t> means secondary alignment record.</a:t>
+            </a:r>
+            <a:endParaRPr lang="en-IT" sz="1400" dirty="0"/>
+          </a:p>
+          <a:p>
+            <a:pPr>
+              <a:buNone/>
+            </a:pPr>
+            <a:r>
+              <a:rPr lang="en-IT" sz="1400" dirty="0"/>
+              <a:t>It does </a:t>
+            </a:r>
+            <a:r>
+              <a:rPr lang="en-IT" sz="1400" b="1" dirty="0"/>
+              <a:t>not</a:t>
+            </a:r>
+            <a:r>
+              <a:rPr lang="en-IT" sz="1400" dirty="0"/>
+              <a:t> mean “this is a multimapping read.”</a:t>
+            </a:r>
+          </a:p>
+          <a:p>
+            <a:pPr>
+              <a:buNone/>
+            </a:pPr>
+            <a:r>
+              <a:rPr lang="en-IT" sz="1400" dirty="0"/>
+              <a:t>Removing secondary records therefore does not automatically remove all ambiguous reads.</a:t>
+            </a:r>
+          </a:p>
+        </p:txBody>
+      </p:sp>
+      <p:sp>
+        <p:nvSpPr>
+          <p:cNvPr id="20" name="TextBox 19">
+            <a:extLst>
+              <a:ext uri="{FF2B5EF4-FFF2-40B4-BE49-F238E27FC236}">
+                <a16:creationId xmlns:a16="http://schemas.microsoft.com/office/drawing/2014/main" id="{3D871451-B2DC-D8EF-E519-2A259147D182}"/>
+              </a:ext>
+            </a:extLst>
+          </p:cNvPr>
+          <p:cNvSpPr txBox="1"/>
+          <p:nvPr/>
+        </p:nvSpPr>
+        <p:spPr>
+          <a:xfrm>
+            <a:off x="7560645" y="2614849"/>
+            <a:ext cx="4114800" cy="2893100"/>
+          </a:xfrm>
+          <a:prstGeom prst="rect">
+            <a:avLst/>
+          </a:prstGeom>
+          <a:noFill/>
+          <a:ln>
+            <a:solidFill>
+              <a:schemeClr val="tx1"/>
+            </a:solidFill>
+          </a:ln>
+        </p:spPr>
+        <p:txBody>
+          <a:bodyPr wrap="square">
+            <a:spAutoFit/>
+          </a:bodyPr>
+          <a:lstStyle/>
+          <a:p>
+            <a:pPr>
+              <a:buNone/>
+            </a:pPr>
+            <a:r>
+              <a:rPr lang="en-IT" sz="1400" b="1" dirty="0"/>
+              <a:t>Good practice for ordinary gene-level RNA-seq</a:t>
+            </a:r>
+            <a:endParaRPr lang="en-IT" sz="1400" dirty="0"/>
+          </a:p>
+          <a:p>
+            <a:pPr>
+              <a:buNone/>
+            </a:pPr>
+            <a:r>
+              <a:rPr lang="en-IT" sz="1400" dirty="0"/>
+              <a:t>Use:</a:t>
+            </a:r>
+          </a:p>
+          <a:p>
+            <a:pPr marL="342900" lvl="0" indent="-342900">
+              <a:buFont typeface="Arial" panose="020B0604020202020204" pitchFamily="34" charset="0"/>
+              <a:buChar char="•"/>
+            </a:pPr>
+            <a:r>
+              <a:rPr lang="en-IT" sz="1400" dirty="0"/>
+              <a:t>primary alignments;</a:t>
+            </a:r>
+          </a:p>
+          <a:p>
+            <a:pPr marL="342900" lvl="0" indent="-342900">
+              <a:buFont typeface="Arial" panose="020B0604020202020204" pitchFamily="34" charset="0"/>
+              <a:buChar char="•"/>
+            </a:pPr>
+            <a:r>
+              <a:rPr lang="en-IT" sz="1400" dirty="0"/>
+              <a:t>appropriate FLAG filtering;</a:t>
+            </a:r>
+          </a:p>
+          <a:p>
+            <a:pPr marL="342900" lvl="0" indent="-342900">
+              <a:buFont typeface="Arial" panose="020B0604020202020204" pitchFamily="34" charset="0"/>
+              <a:buChar char="•"/>
+            </a:pPr>
+            <a:r>
+              <a:rPr lang="en-IT" sz="1400" dirty="0"/>
+              <a:t>an aligner-appropriate MAPQ threshold.</a:t>
+            </a:r>
+          </a:p>
+          <a:p>
+            <a:pPr>
+              <a:buNone/>
+            </a:pPr>
+            <a:endParaRPr lang="en-IT" sz="1400" dirty="0"/>
+          </a:p>
+          <a:p>
+            <a:pPr>
+              <a:buNone/>
+            </a:pPr>
+            <a:r>
+              <a:rPr lang="en-IT" sz="1400" dirty="0"/>
+              <a:t>Do not treat one MAPQ cutoff as universal across aligners.</a:t>
+            </a:r>
+          </a:p>
+          <a:p>
+            <a:pPr>
+              <a:buNone/>
+            </a:pPr>
+            <a:r>
+              <a:rPr lang="en-IT" sz="1400" b="1" dirty="0"/>
+              <a:t>Bowtie2, STAR and HISAT2 encode multimapping differently.</a:t>
+            </a:r>
+            <a:endParaRPr lang="en-IT" sz="1400" dirty="0"/>
+          </a:p>
+          <a:p>
+            <a:pPr>
+              <a:buNone/>
+            </a:pPr>
+            <a:r>
+              <a:rPr lang="en-IT" sz="1400" dirty="0"/>
+              <a:t>STAR and HISAT2 can provide </a:t>
+            </a:r>
+            <a:r>
+              <a:rPr lang="en-IT" sz="1400" dirty="0">
+                <a:latin typeface="+mn-lt"/>
+              </a:rPr>
+              <a:t>NH</a:t>
+            </a:r>
+            <a:r>
+              <a:rPr lang="en-IT" sz="1400" dirty="0"/>
+              <a:t>, whereas Bowtie2 relies strongly on alignment scores, alternative alignments and MAPQ.</a:t>
+            </a:r>
+          </a:p>
+        </p:txBody>
+      </p:sp>
+    </p:spTree>
+    <p:extLst>
+      <p:ext uri="{BB962C8B-B14F-4D97-AF65-F5344CB8AC3E}">
+        <p14:creationId xmlns:p14="http://schemas.microsoft.com/office/powerpoint/2010/main" val="276217916"/>
+      </p:ext>
+    </p:extLst>
+  </p:cSld>
+  <p:clrMapOvr>
+    <a:masterClrMapping/>
+  </p:clrMapOvr>
+  <p:timing>
+    <p:tnLst>
+      <p:par>
+        <p:cTn id="1" dur="indefinite" restart="never" nodeType="tmRoot">
+          <p:childTnLst>
+            <p:seq concurrent="1" nextAc="seek">
+              <p:cTn id="2" dur="indefinite" nodeType="mainSeq">
+                <p:childTnLst>
+                  <p:par>
+                    <p:cTn id="3" fill="hold">
+                      <p:stCondLst>
+                        <p:cond delay="indefinite"/>
+                      </p:stCondLst>
+                      <p:childTnLst>
+                        <p:par>
+                          <p:cTn id="4" fill="hold">
+                            <p:stCondLst>
+                              <p:cond delay="0"/>
+                            </p:stCondLst>
+                            <p:childTnLst>
+                              <p:par>
+                                <p:cTn id="5" presetID="1" presetClass="entr" presetSubtype="0" fill="hold" grpId="0" nodeType="clickEffect">
+                                  <p:stCondLst>
+                                    <p:cond delay="0"/>
+                                  </p:stCondLst>
+                                  <p:childTnLst>
+                                    <p:set>
+                                      <p:cBhvr>
+                                        <p:cTn id="6" dur="1" fill="hold">
+                                          <p:stCondLst>
+                                            <p:cond delay="0"/>
+                                          </p:stCondLst>
+                                        </p:cTn>
+                                        <p:tgtEl>
+                                          <p:spTgt spid="8"/>
+                                        </p:tgtEl>
+                                        <p:attrNameLst>
+                                          <p:attrName>style.visibility</p:attrName>
+                                        </p:attrNameLst>
+                                      </p:cBhvr>
+                                      <p:to>
+                                        <p:strVal val="visible"/>
+                                      </p:to>
+                                    </p:set>
+                                  </p:childTnLst>
+                                </p:cTn>
+                              </p:par>
+                            </p:childTnLst>
+                          </p:cTn>
+                        </p:par>
+                      </p:childTnLst>
+                    </p:cTn>
+                  </p:par>
+                  <p:par>
+                    <p:cTn id="7" fill="hold">
+                      <p:stCondLst>
+                        <p:cond delay="indefinite"/>
+                      </p:stCondLst>
+                      <p:childTnLst>
+                        <p:par>
+                          <p:cTn id="8" fill="hold">
+                            <p:stCondLst>
+                              <p:cond delay="0"/>
+                            </p:stCondLst>
+                            <p:childTnLst>
+                              <p:par>
+                                <p:cTn id="9" presetID="1" presetClass="entr" presetSubtype="0" fill="hold" grpId="0" nodeType="clickEffect">
+                                  <p:stCondLst>
+                                    <p:cond delay="0"/>
+                                  </p:stCondLst>
+                                  <p:childTnLst>
+                                    <p:set>
+                                      <p:cBhvr>
+                                        <p:cTn id="10" dur="1" fill="hold">
+                                          <p:stCondLst>
+                                            <p:cond delay="0"/>
+                                          </p:stCondLst>
+                                        </p:cTn>
+                                        <p:tgtEl>
+                                          <p:spTgt spid="11"/>
+                                        </p:tgtEl>
+                                        <p:attrNameLst>
+                                          <p:attrName>style.visibility</p:attrName>
+                                        </p:attrNameLst>
+                                      </p:cBhvr>
+                                      <p:to>
+                                        <p:strVal val="visible"/>
+                                      </p:to>
+                                    </p:set>
+                                  </p:childTnLst>
+                                </p:cTn>
+                              </p:par>
+                            </p:childTnLst>
+                          </p:cTn>
+                        </p:par>
+                      </p:childTnLst>
+                    </p:cTn>
+                  </p:par>
+                  <p:par>
+                    <p:cTn id="11" fill="hold">
+                      <p:stCondLst>
+                        <p:cond delay="indefinite"/>
+                      </p:stCondLst>
+                      <p:childTnLst>
+                        <p:par>
+                          <p:cTn id="12" fill="hold">
+                            <p:stCondLst>
+                              <p:cond delay="0"/>
+                            </p:stCondLst>
+                            <p:childTnLst>
+                              <p:par>
+                                <p:cTn id="13" presetID="1" presetClass="entr" presetSubtype="0" fill="hold" grpId="0" nodeType="clickEffect">
+                                  <p:stCondLst>
+                                    <p:cond delay="0"/>
+                                  </p:stCondLst>
+                                  <p:childTnLst>
+                                    <p:set>
+                                      <p:cBhvr>
+                                        <p:cTn id="14" dur="1" fill="hold">
+                                          <p:stCondLst>
+                                            <p:cond delay="0"/>
+                                          </p:stCondLst>
+                                        </p:cTn>
+                                        <p:tgtEl>
+                                          <p:spTgt spid="13"/>
+                                        </p:tgtEl>
+                                        <p:attrNameLst>
+                                          <p:attrName>style.visibility</p:attrName>
+                                        </p:attrNameLst>
+                                      </p:cBhvr>
+                                      <p:to>
+                                        <p:strVal val="visible"/>
+                                      </p:to>
+                                    </p:set>
+                                  </p:childTnLst>
+                                </p:cTn>
+                              </p:par>
+                            </p:childTnLst>
+                          </p:cTn>
+                        </p:par>
+                      </p:childTnLst>
+                    </p:cTn>
+                  </p:par>
+                  <p:par>
+                    <p:cTn id="15" fill="hold">
+                      <p:stCondLst>
+                        <p:cond delay="indefinite"/>
+                      </p:stCondLst>
+                      <p:childTnLst>
+                        <p:par>
+                          <p:cTn id="16" fill="hold">
+                            <p:stCondLst>
+                              <p:cond delay="0"/>
+                            </p:stCondLst>
+                            <p:childTnLst>
+                              <p:par>
+                                <p:cTn id="17" presetID="1" presetClass="entr" presetSubtype="0" fill="hold" grpId="0" nodeType="clickEffect">
+                                  <p:stCondLst>
+                                    <p:cond delay="0"/>
+                                  </p:stCondLst>
+                                  <p:childTnLst>
+                                    <p:set>
+                                      <p:cBhvr>
+                                        <p:cTn id="18" dur="1" fill="hold">
+                                          <p:stCondLst>
+                                            <p:cond delay="0"/>
+                                          </p:stCondLst>
+                                        </p:cTn>
+                                        <p:tgtEl>
+                                          <p:spTgt spid="17"/>
+                                        </p:tgtEl>
+                                        <p:attrNameLst>
+                                          <p:attrName>style.visibility</p:attrName>
+                                        </p:attrNameLst>
+                                      </p:cBhvr>
+                                      <p:to>
+                                        <p:strVal val="visible"/>
+                                      </p:to>
+                                    </p:set>
+                                  </p:childTnLst>
+                                </p:cTn>
+                              </p:par>
+                              <p:par>
+                                <p:cTn id="19" presetID="1" presetClass="entr" presetSubtype="0" fill="hold" grpId="0" nodeType="withEffect">
+                                  <p:stCondLst>
+                                    <p:cond delay="0"/>
+                                  </p:stCondLst>
+                                  <p:childTnLst>
+                                    <p:set>
+                                      <p:cBhvr>
+                                        <p:cTn id="20" dur="1" fill="hold">
+                                          <p:stCondLst>
+                                            <p:cond delay="0"/>
+                                          </p:stCondLst>
+                                        </p:cTn>
+                                        <p:tgtEl>
+                                          <p:spTgt spid="15"/>
+                                        </p:tgtEl>
+                                        <p:attrNameLst>
+                                          <p:attrName>style.visibility</p:attrName>
+                                        </p:attrNameLst>
+                                      </p:cBhvr>
+                                      <p:to>
+                                        <p:strVal val="visible"/>
+                                      </p:to>
+                                    </p:set>
+                                  </p:childTnLst>
+                                </p:cTn>
+                              </p:par>
+                              <p:par>
+                                <p:cTn id="21" presetID="1" presetClass="entr" presetSubtype="0" fill="hold" grpId="0" nodeType="withEffect">
+                                  <p:stCondLst>
+                                    <p:cond delay="0"/>
+                                  </p:stCondLst>
+                                  <p:childTnLst>
+                                    <p:set>
+                                      <p:cBhvr>
+                                        <p:cTn id="22" dur="1" fill="hold">
+                                          <p:stCondLst>
+                                            <p:cond delay="0"/>
+                                          </p:stCondLst>
+                                        </p:cTn>
+                                        <p:tgtEl>
+                                          <p:spTgt spid="19"/>
+                                        </p:tgtEl>
+                                        <p:attrNameLst>
+                                          <p:attrName>style.visibility</p:attrName>
+                                        </p:attrNameLst>
+                                      </p:cBhvr>
+                                      <p:to>
+                                        <p:strVal val="visible"/>
+                                      </p:to>
+                                    </p:set>
+                                  </p:childTnLst>
+                                </p:cTn>
+                              </p:par>
+                            </p:childTnLst>
+                          </p:cTn>
+                        </p:par>
+                      </p:childTnLst>
+                    </p:cTn>
+                  </p:par>
+                  <p:par>
+                    <p:cTn id="23" fill="hold">
+                      <p:stCondLst>
+                        <p:cond delay="indefinite"/>
+                      </p:stCondLst>
+                      <p:childTnLst>
+                        <p:par>
+                          <p:cTn id="24" fill="hold">
+                            <p:stCondLst>
+                              <p:cond delay="0"/>
+                            </p:stCondLst>
+                            <p:childTnLst>
+                              <p:par>
+                                <p:cTn id="25" presetID="1" presetClass="entr" presetSubtype="0" fill="hold" grpId="0" nodeType="clickEffect">
+                                  <p:stCondLst>
+                                    <p:cond delay="0"/>
+                                  </p:stCondLst>
+                                  <p:childTnLst>
+                                    <p:set>
+                                      <p:cBhvr>
+                                        <p:cTn id="26" dur="1" fill="hold">
+                                          <p:stCondLst>
+                                            <p:cond delay="0"/>
+                                          </p:stCondLst>
+                                        </p:cTn>
+                                        <p:tgtEl>
+                                          <p:spTgt spid="20"/>
+                                        </p:tgtEl>
+                                        <p:attrNameLst>
+                                          <p:attrName>style.visibility</p:attrName>
+                                        </p:attrNameLst>
+                                      </p:cBhvr>
+                                      <p:to>
+                                        <p:strVal val="visible"/>
+                                      </p:to>
+                                    </p:set>
+                                  </p:childTnLst>
+                                </p:cTn>
+                              </p:par>
+                            </p:childTnLst>
+                          </p:cTn>
+                        </p:par>
+                      </p:childTnLst>
+                    </p:cTn>
+                  </p:par>
+                </p:childTnLst>
+              </p:cTn>
+              <p:prevCondLst>
+                <p:cond evt="onPrev" delay="0">
+                  <p:tgtEl>
+                    <p:sldTgt/>
+                  </p:tgtEl>
+                </p:cond>
+              </p:prevCondLst>
+              <p:nextCondLst>
+                <p:cond evt="onNext" delay="0">
+                  <p:tgtEl>
+                    <p:sldTgt/>
+                  </p:tgtEl>
+                </p:cond>
+              </p:nextCondLst>
+            </p:seq>
+          </p:childTnLst>
+        </p:cTn>
+      </p:par>
+    </p:tnLst>
+    <p:bldLst>
+      <p:bldP spid="8" grpId="0" animBg="1"/>
+      <p:bldP spid="11" grpId="0" animBg="1"/>
+      <p:bldP spid="13" grpId="0" animBg="1"/>
+      <p:bldP spid="15" grpId="0"/>
+      <p:bldP spid="17" grpId="0"/>
+      <p:bldP spid="19" grpId="0"/>
+      <p:bldP spid="20" grpId="0" animBg="1"/>
+    </p:bldLst>
+  </p:timing>
+</p:sld>
+</file>
+
+<file path=ppt/slides/slide7.xml><?xml version="1.0" encoding="utf-8"?>
+<p:sld xmlns:a="http://schemas.openxmlformats.org/drawingml/2006/main" xmlns:r="http://schemas.openxmlformats.org/officeDocument/2006/relationships" xmlns:p="http://schemas.openxmlformats.org/presentationml/2006/main">
+  <p:cSld>
+    <p:spTree>
+      <p:nvGrpSpPr>
+        <p:cNvPr id="1" name=""/>
+        <p:cNvGrpSpPr/>
+        <p:nvPr/>
+      </p:nvGrpSpPr>
+      <p:grpSpPr>
+        <a:xfrm>
+          <a:off x="0" y="0"/>
+          <a:ext cx="0" cy="0"/>
+          <a:chOff x="0" y="0"/>
+          <a:chExt cx="0" cy="0"/>
+        </a:xfrm>
+      </p:grpSpPr>
+      <p:sp>
+        <p:nvSpPr>
+          <p:cNvPr id="2" name="Title 1">
+            <a:extLst>
+              <a:ext uri="{FF2B5EF4-FFF2-40B4-BE49-F238E27FC236}">
+                <a16:creationId xmlns:a16="http://schemas.microsoft.com/office/drawing/2014/main" id="{2402A835-09AA-FDEC-84C7-83E050D99880}"/>
+              </a:ext>
+            </a:extLst>
+          </p:cNvPr>
+          <p:cNvSpPr>
+            <a:spLocks noGrp="1"/>
+          </p:cNvSpPr>
+          <p:nvPr>
+            <p:ph type="title"/>
+          </p:nvPr>
+        </p:nvSpPr>
+        <p:spPr/>
+        <p:txBody>
+          <a:bodyPr>
+            <a:normAutofit fontScale="90000"/>
+          </a:bodyPr>
+          <a:lstStyle/>
+          <a:p>
+            <a:r>
+              <a:rPr lang="en-IT" dirty="0"/>
+              <a:t>2) Multi-mapping: ambiguity is not binary</a:t>
+            </a:r>
+            <a:endParaRPr lang="en-GB" dirty="0"/>
+          </a:p>
+        </p:txBody>
+      </p:sp>
+      <p:sp>
+        <p:nvSpPr>
+          <p:cNvPr id="4" name="Date Placeholder 3">
+            <a:extLst>
+              <a:ext uri="{FF2B5EF4-FFF2-40B4-BE49-F238E27FC236}">
+                <a16:creationId xmlns:a16="http://schemas.microsoft.com/office/drawing/2014/main" id="{CFE23F39-4350-C63D-0E06-EE8F3420FF97}"/>
+              </a:ext>
+            </a:extLst>
+          </p:cNvPr>
+          <p:cNvSpPr>
+            <a:spLocks noGrp="1"/>
+          </p:cNvSpPr>
+          <p:nvPr>
+            <p:ph type="dt" sz="half" idx="10"/>
+          </p:nvPr>
+        </p:nvSpPr>
+        <p:spPr/>
+        <p:txBody>
+          <a:bodyPr/>
+          <a:lstStyle/>
+          <a:p>
+            <a:fld id="{761DFEEA-1162-B343-ACBF-B3E92F6AC390}" type="datetime1">
+              <a:rPr lang="it-IT" smtClean="0"/>
+              <a:t>15/10/26</a:t>
+            </a:fld>
+            <a:endParaRPr lang="en-GB"/>
+          </a:p>
+        </p:txBody>
+      </p:sp>
+      <p:sp>
+        <p:nvSpPr>
+          <p:cNvPr id="5" name="Footer Placeholder 4">
+            <a:extLst>
+              <a:ext uri="{FF2B5EF4-FFF2-40B4-BE49-F238E27FC236}">
+                <a16:creationId xmlns:a16="http://schemas.microsoft.com/office/drawing/2014/main" id="{0CD0A759-B5A1-CAC9-9AF0-3B45037E9056}"/>
+              </a:ext>
+            </a:extLst>
+          </p:cNvPr>
+          <p:cNvSpPr>
+            <a:spLocks noGrp="1"/>
+          </p:cNvSpPr>
+          <p:nvPr>
+            <p:ph type="ftr" sz="quarter" idx="11"/>
+          </p:nvPr>
+        </p:nvSpPr>
+        <p:spPr/>
+        <p:txBody>
+          <a:bodyPr/>
+          <a:lstStyle/>
+          <a:p>
+            <a:r>
+              <a:rPr lang="en-GB"/>
+              <a:t>Day 1: Reproducible NGS Data Analysis on Personal Laptops</a:t>
+            </a:r>
+          </a:p>
+        </p:txBody>
+      </p:sp>
+      <p:sp>
+        <p:nvSpPr>
+          <p:cNvPr id="6" name="Slide Number Placeholder 5">
+            <a:extLst>
+              <a:ext uri="{FF2B5EF4-FFF2-40B4-BE49-F238E27FC236}">
+                <a16:creationId xmlns:a16="http://schemas.microsoft.com/office/drawing/2014/main" id="{9EE10E1E-7148-718D-0C1B-3EC3C9074E94}"/>
+              </a:ext>
+            </a:extLst>
+          </p:cNvPr>
+          <p:cNvSpPr>
+            <a:spLocks noGrp="1"/>
+          </p:cNvSpPr>
+          <p:nvPr>
+            <p:ph type="sldNum" sz="quarter" idx="12"/>
+          </p:nvPr>
+        </p:nvSpPr>
+        <p:spPr/>
+        <p:txBody>
+          <a:bodyPr/>
+          <a:lstStyle/>
+          <a:p>
+            <a:fld id="{62E92BA6-6E87-3343-8D2C-B7A656D628E4}" type="slidenum">
+              <a:rPr lang="en-GB" smtClean="0"/>
+              <a:t>6</a:t>
+            </a:fld>
+            <a:endParaRPr lang="en-GB"/>
+          </a:p>
+        </p:txBody>
+      </p:sp>
+      <p:sp>
+        <p:nvSpPr>
+          <p:cNvPr id="8" name="TextBox 7">
+            <a:extLst>
+              <a:ext uri="{FF2B5EF4-FFF2-40B4-BE49-F238E27FC236}">
+                <a16:creationId xmlns:a16="http://schemas.microsoft.com/office/drawing/2014/main" id="{A48CC82F-6CC3-A328-5671-A10098C831F2}"/>
+              </a:ext>
+            </a:extLst>
+          </p:cNvPr>
+          <p:cNvSpPr txBox="1"/>
+          <p:nvPr/>
+        </p:nvSpPr>
+        <p:spPr>
+          <a:xfrm>
+            <a:off x="269997" y="940750"/>
+            <a:ext cx="11652006" cy="461665"/>
+          </a:xfrm>
+          <a:prstGeom prst="rect">
+            <a:avLst/>
+          </a:prstGeom>
+          <a:noFill/>
+        </p:spPr>
+        <p:txBody>
+          <a:bodyPr wrap="square">
+            <a:spAutoFit/>
+          </a:bodyPr>
+          <a:lstStyle/>
+          <a:p>
+            <a:r>
+              <a:rPr lang="en-IT" sz="2400" dirty="0"/>
+              <a:t>Should we remove multimappers?</a:t>
+            </a:r>
+            <a:endParaRPr lang="en-GB" sz="2400" dirty="0"/>
+          </a:p>
+        </p:txBody>
+      </p:sp>
+      <p:sp>
+        <p:nvSpPr>
+          <p:cNvPr id="10" name="TextBox 9">
+            <a:extLst>
+              <a:ext uri="{FF2B5EF4-FFF2-40B4-BE49-F238E27FC236}">
+                <a16:creationId xmlns:a16="http://schemas.microsoft.com/office/drawing/2014/main" id="{DEEB5139-B69A-EC54-7C2A-C50579A3808B}"/>
+              </a:ext>
+            </a:extLst>
+          </p:cNvPr>
+          <p:cNvSpPr txBox="1"/>
+          <p:nvPr/>
+        </p:nvSpPr>
+        <p:spPr>
+          <a:xfrm>
+            <a:off x="269996" y="1507565"/>
+            <a:ext cx="11652005" cy="3970318"/>
+          </a:xfrm>
+          <a:prstGeom prst="rect">
+            <a:avLst/>
+          </a:prstGeom>
+          <a:noFill/>
+        </p:spPr>
+        <p:txBody>
+          <a:bodyPr wrap="square">
+            <a:spAutoFit/>
+          </a:bodyPr>
+          <a:lstStyle/>
+          <a:p>
+            <a:pPr>
+              <a:buNone/>
+            </a:pPr>
+            <a:r>
+              <a:rPr lang="en-IT" b="1" dirty="0">
+                <a:solidFill>
+                  <a:schemeClr val="accent4">
+                    <a:lumMod val="75000"/>
+                  </a:schemeClr>
+                </a:solidFill>
+              </a:rPr>
+              <a:t>NOT ALWAYS</a:t>
+            </a:r>
+          </a:p>
+          <a:p>
+            <a:pPr>
+              <a:buNone/>
+            </a:pPr>
+            <a:r>
+              <a:rPr lang="en-IT" dirty="0"/>
+              <a:t>For standard gene-level differential expression, ambiguous reads can make assignment to individual genes uncertain.</a:t>
+            </a:r>
+          </a:p>
+          <a:p>
+            <a:pPr>
+              <a:buNone/>
+            </a:pPr>
+            <a:r>
+              <a:rPr lang="en-IT" dirty="0"/>
+              <a:t>Confidence filtering is therefore usually sensible.</a:t>
+            </a:r>
+          </a:p>
+          <a:p>
+            <a:pPr>
+              <a:buNone/>
+            </a:pPr>
+            <a:endParaRPr lang="en-IT" dirty="0"/>
+          </a:p>
+          <a:p>
+            <a:pPr>
+              <a:buNone/>
+            </a:pPr>
+            <a:r>
+              <a:rPr lang="en-IT" dirty="0"/>
+              <a:t>But multimappers can be the </a:t>
+            </a:r>
+            <a:r>
+              <a:rPr lang="en-IT" b="1" dirty="0"/>
+              <a:t>signal of interest</a:t>
+            </a:r>
+            <a:r>
+              <a:rPr lang="en-IT" dirty="0"/>
+              <a:t> when studying:</a:t>
+            </a:r>
+          </a:p>
+          <a:p>
+            <a:pPr marL="342900" lvl="0" indent="-342900">
+              <a:buFont typeface="Arial" panose="020B0604020202020204" pitchFamily="34" charset="0"/>
+              <a:buChar char="•"/>
+            </a:pPr>
+            <a:r>
+              <a:rPr lang="en-IT" dirty="0"/>
+              <a:t>transposable elements;</a:t>
+            </a:r>
+          </a:p>
+          <a:p>
+            <a:pPr marL="342900" lvl="0" indent="-342900">
+              <a:buFont typeface="Arial" panose="020B0604020202020204" pitchFamily="34" charset="0"/>
+              <a:buChar char="•"/>
+            </a:pPr>
+            <a:r>
+              <a:rPr lang="en-IT" dirty="0"/>
+              <a:t>repetitive transcripts;</a:t>
+            </a:r>
+          </a:p>
+          <a:p>
+            <a:pPr marL="342900" lvl="0" indent="-342900">
+              <a:buFont typeface="Arial" panose="020B0604020202020204" pitchFamily="34" charset="0"/>
+              <a:buChar char="•"/>
+            </a:pPr>
+            <a:r>
+              <a:rPr lang="en-IT" dirty="0"/>
+              <a:t>paralogous genes;</a:t>
+            </a:r>
+          </a:p>
+          <a:p>
+            <a:pPr marL="342900" lvl="0" indent="-342900">
+              <a:buFont typeface="Arial" panose="020B0604020202020204" pitchFamily="34" charset="0"/>
+              <a:buChar char="•"/>
+            </a:pPr>
+            <a:r>
+              <a:rPr lang="en-IT" dirty="0"/>
+              <a:t>duplicated gene families;</a:t>
+            </a:r>
+          </a:p>
+          <a:p>
+            <a:pPr marL="342900" lvl="0" indent="-342900">
+              <a:buFont typeface="Arial" panose="020B0604020202020204" pitchFamily="34" charset="0"/>
+              <a:buChar char="•"/>
+            </a:pPr>
+            <a:r>
+              <a:rPr lang="en-IT" dirty="0"/>
+              <a:t>multicopy sequences.</a:t>
+            </a:r>
+          </a:p>
+          <a:p>
+            <a:pPr>
+              <a:buNone/>
+            </a:pPr>
+            <a:endParaRPr lang="en-IT" dirty="0"/>
+          </a:p>
+          <a:p>
+            <a:pPr>
+              <a:buNone/>
+            </a:pPr>
+            <a:r>
+              <a:rPr lang="en-IT" dirty="0"/>
+              <a:t>Simply deleting multimappers in these analyses preferentially deletes biologically relevant information.</a:t>
+            </a:r>
+          </a:p>
+          <a:p>
+            <a:pPr>
+              <a:buNone/>
+            </a:pPr>
+            <a:r>
+              <a:rPr lang="en-IT" dirty="0"/>
+              <a:t>The appropriate strategy may instead involve a quantification method capable of assigning or probabilistically modelling ambiguous reads.</a:t>
+            </a:r>
+          </a:p>
+        </p:txBody>
+      </p:sp>
+    </p:spTree>
+    <p:extLst>
+      <p:ext uri="{BB962C8B-B14F-4D97-AF65-F5344CB8AC3E}">
+        <p14:creationId xmlns:p14="http://schemas.microsoft.com/office/powerpoint/2010/main" val="3354058391"/>
+      </p:ext>
+    </p:extLst>
+  </p:cSld>
+  <p:clrMapOvr>
+    <a:masterClrMapping/>
+  </p:clrMapOvr>
+</p:sld>
+</file>
+
+<file path=ppt/slides/slide8.xml><?xml version="1.0" encoding="utf-8"?>
+<p:sld xmlns:a="http://schemas.openxmlformats.org/drawingml/2006/main" xmlns:r="http://schemas.openxmlformats.org/officeDocument/2006/relationships" xmlns:p="http://schemas.openxmlformats.org/presentationml/2006/main">
+  <p:cSld>
+    <p:spTree>
+      <p:nvGrpSpPr>
+        <p:cNvPr id="1" name=""/>
+        <p:cNvGrpSpPr/>
+        <p:nvPr/>
+      </p:nvGrpSpPr>
+      <p:grpSpPr>
+        <a:xfrm>
+          <a:off x="0" y="0"/>
+          <a:ext cx="0" cy="0"/>
+          <a:chOff x="0" y="0"/>
+          <a:chExt cx="0" cy="0"/>
+        </a:xfrm>
+      </p:grpSpPr>
+      <p:sp>
+        <p:nvSpPr>
+          <p:cNvPr id="2" name="Title 1">
+            <a:extLst>
+              <a:ext uri="{FF2B5EF4-FFF2-40B4-BE49-F238E27FC236}">
+                <a16:creationId xmlns:a16="http://schemas.microsoft.com/office/drawing/2014/main" id="{702AF94D-5B5D-8D3C-64DD-EC48435B09B5}"/>
+              </a:ext>
+            </a:extLst>
+          </p:cNvPr>
+          <p:cNvSpPr>
+            <a:spLocks noGrp="1"/>
+          </p:cNvSpPr>
+          <p:nvPr>
+            <p:ph type="title"/>
+          </p:nvPr>
+        </p:nvSpPr>
+        <p:spPr/>
+        <p:txBody>
+          <a:bodyPr>
+            <a:normAutofit fontScale="90000"/>
+          </a:bodyPr>
+          <a:lstStyle/>
+          <a:p>
+            <a:r>
+              <a:rPr lang="en-GB" dirty="0"/>
+              <a:t>3) </a:t>
+            </a:r>
+            <a:r>
+              <a:rPr lang="en-IT" dirty="0"/>
+              <a:t>Residual rRNA</a:t>
+            </a:r>
+            <a:endParaRPr lang="en-GB" dirty="0"/>
+          </a:p>
+        </p:txBody>
+      </p:sp>
+      <p:sp>
+        <p:nvSpPr>
+          <p:cNvPr id="4" name="Date Placeholder 3">
+            <a:extLst>
+              <a:ext uri="{FF2B5EF4-FFF2-40B4-BE49-F238E27FC236}">
+                <a16:creationId xmlns:a16="http://schemas.microsoft.com/office/drawing/2014/main" id="{414E314E-AF5F-D2DA-04DF-37D8175608EE}"/>
+              </a:ext>
+            </a:extLst>
+          </p:cNvPr>
+          <p:cNvSpPr>
+            <a:spLocks noGrp="1"/>
+          </p:cNvSpPr>
+          <p:nvPr>
+            <p:ph type="dt" sz="half" idx="10"/>
+          </p:nvPr>
+        </p:nvSpPr>
+        <p:spPr/>
+        <p:txBody>
+          <a:bodyPr/>
+          <a:lstStyle/>
+          <a:p>
+            <a:fld id="{761DFEEA-1162-B343-ACBF-B3E92F6AC390}" type="datetime1">
+              <a:rPr lang="it-IT" smtClean="0"/>
+              <a:t>15/10/26</a:t>
+            </a:fld>
+            <a:endParaRPr lang="en-GB"/>
+          </a:p>
+        </p:txBody>
+      </p:sp>
+      <p:sp>
+        <p:nvSpPr>
+          <p:cNvPr id="5" name="Footer Placeholder 4">
+            <a:extLst>
+              <a:ext uri="{FF2B5EF4-FFF2-40B4-BE49-F238E27FC236}">
+                <a16:creationId xmlns:a16="http://schemas.microsoft.com/office/drawing/2014/main" id="{FA348BFB-037B-7B83-0BD1-846C9D90B404}"/>
+              </a:ext>
+            </a:extLst>
+          </p:cNvPr>
+          <p:cNvSpPr>
+            <a:spLocks noGrp="1"/>
+          </p:cNvSpPr>
+          <p:nvPr>
+            <p:ph type="ftr" sz="quarter" idx="11"/>
+          </p:nvPr>
+        </p:nvSpPr>
+        <p:spPr/>
+        <p:txBody>
+          <a:bodyPr/>
+          <a:lstStyle/>
+          <a:p>
+            <a:r>
+              <a:rPr lang="en-GB"/>
+              <a:t>Day 1: Reproducible NGS Data Analysis on Personal Laptops</a:t>
+            </a:r>
+          </a:p>
+        </p:txBody>
+      </p:sp>
+      <p:sp>
+        <p:nvSpPr>
+          <p:cNvPr id="6" name="Slide Number Placeholder 5">
+            <a:extLst>
+              <a:ext uri="{FF2B5EF4-FFF2-40B4-BE49-F238E27FC236}">
+                <a16:creationId xmlns:a16="http://schemas.microsoft.com/office/drawing/2014/main" id="{13BDFAA1-00D2-8B36-6DD9-5271F2A554C8}"/>
+              </a:ext>
+            </a:extLst>
+          </p:cNvPr>
+          <p:cNvSpPr>
+            <a:spLocks noGrp="1"/>
+          </p:cNvSpPr>
+          <p:nvPr>
+            <p:ph type="sldNum" sz="quarter" idx="12"/>
+          </p:nvPr>
+        </p:nvSpPr>
+        <p:spPr/>
+        <p:txBody>
+          <a:bodyPr/>
+          <a:lstStyle/>
+          <a:p>
+            <a:fld id="{62E92BA6-6E87-3343-8D2C-B7A656D628E4}" type="slidenum">
+              <a:rPr lang="en-GB" smtClean="0"/>
+              <a:t>7</a:t>
+            </a:fld>
+            <a:endParaRPr lang="en-GB"/>
+          </a:p>
+        </p:txBody>
+      </p:sp>
+      <p:sp>
+        <p:nvSpPr>
+          <p:cNvPr id="8" name="TextBox 7">
+            <a:extLst>
+              <a:ext uri="{FF2B5EF4-FFF2-40B4-BE49-F238E27FC236}">
+                <a16:creationId xmlns:a16="http://schemas.microsoft.com/office/drawing/2014/main" id="{1AD6CF4D-A922-6294-669A-EDA254751464}"/>
+              </a:ext>
+            </a:extLst>
+          </p:cNvPr>
+          <p:cNvSpPr txBox="1"/>
+          <p:nvPr/>
+        </p:nvSpPr>
+        <p:spPr>
+          <a:xfrm>
+            <a:off x="287948" y="824107"/>
+            <a:ext cx="11757514" cy="2308324"/>
+          </a:xfrm>
+          <a:prstGeom prst="rect">
+            <a:avLst/>
+          </a:prstGeom>
+          <a:noFill/>
+        </p:spPr>
+        <p:txBody>
+          <a:bodyPr wrap="square">
+            <a:spAutoFit/>
+          </a:bodyPr>
+          <a:lstStyle/>
+          <a:p>
+            <a:pPr>
+              <a:buNone/>
+            </a:pPr>
+            <a:r>
+              <a:rPr lang="en-IT" dirty="0"/>
+              <a:t>Ribosomal RNA constitutes a very large fraction of cellular RNA.</a:t>
+            </a:r>
+          </a:p>
+          <a:p>
+            <a:pPr>
+              <a:buNone/>
+            </a:pPr>
+            <a:endParaRPr lang="en-IT" dirty="0"/>
+          </a:p>
+          <a:p>
+            <a:pPr>
+              <a:buNone/>
+            </a:pPr>
+            <a:r>
+              <a:rPr lang="en-IT" dirty="0"/>
+              <a:t>RNA-seq protocols therefore commonly use:</a:t>
+            </a:r>
+          </a:p>
+          <a:p>
+            <a:pPr marL="342900" lvl="0" indent="-342900">
+              <a:buFont typeface="Arial" panose="020B0604020202020204" pitchFamily="34" charset="0"/>
+              <a:buChar char="•"/>
+            </a:pPr>
+            <a:r>
+              <a:rPr lang="en-IT" dirty="0"/>
+              <a:t>rRNA depletion;</a:t>
+            </a:r>
+          </a:p>
+          <a:p>
+            <a:pPr marL="342900" lvl="0" indent="-342900">
+              <a:buFont typeface="Arial" panose="020B0604020202020204" pitchFamily="34" charset="0"/>
+              <a:buChar char="•"/>
+            </a:pPr>
+            <a:r>
+              <a:rPr lang="en-IT" dirty="0"/>
+              <a:t>poly(A) selection in appropriate organisms/applications;</a:t>
+            </a:r>
+          </a:p>
+          <a:p>
+            <a:pPr marL="342900" lvl="0" indent="-342900">
+              <a:buFont typeface="Arial" panose="020B0604020202020204" pitchFamily="34" charset="0"/>
+              <a:buChar char="•"/>
+            </a:pPr>
+            <a:r>
+              <a:rPr lang="en-IT" dirty="0"/>
+              <a:t>other targeted enrichment/depletion strategies.</a:t>
+            </a:r>
+          </a:p>
+          <a:p>
+            <a:pPr>
+              <a:buNone/>
+            </a:pPr>
+            <a:endParaRPr lang="en-IT" dirty="0"/>
+          </a:p>
+          <a:p>
+            <a:pPr>
+              <a:buNone/>
+            </a:pPr>
+            <a:r>
+              <a:rPr lang="en-IT" dirty="0"/>
+              <a:t>Residual rRNA represents sequencing capacity that may contribute little to the intended gene-expression analysis.</a:t>
+            </a:r>
+          </a:p>
+        </p:txBody>
+      </p:sp>
+      <p:sp>
+        <p:nvSpPr>
+          <p:cNvPr id="10" name="TextBox 9">
+            <a:extLst>
+              <a:ext uri="{FF2B5EF4-FFF2-40B4-BE49-F238E27FC236}">
+                <a16:creationId xmlns:a16="http://schemas.microsoft.com/office/drawing/2014/main" id="{4186D743-6578-5C92-C36A-3D8533A3A50E}"/>
+              </a:ext>
+            </a:extLst>
+          </p:cNvPr>
+          <p:cNvSpPr txBox="1"/>
+          <p:nvPr/>
+        </p:nvSpPr>
+        <p:spPr>
+          <a:xfrm>
+            <a:off x="358285" y="3265663"/>
+            <a:ext cx="6737105" cy="1200329"/>
+          </a:xfrm>
+          <a:prstGeom prst="rect">
+            <a:avLst/>
+          </a:prstGeom>
+          <a:noFill/>
+          <a:ln>
+            <a:solidFill>
+              <a:schemeClr val="tx1"/>
+            </a:solidFill>
+          </a:ln>
+        </p:spPr>
+        <p:txBody>
+          <a:bodyPr wrap="square">
+            <a:spAutoFit/>
+          </a:bodyPr>
+          <a:lstStyle/>
+          <a:p>
+            <a:pPr marL="342900" lvl="0" indent="-342900">
+              <a:buFont typeface="Arial" panose="020B0604020202020204" pitchFamily="34" charset="0"/>
+              <a:buChar char="•"/>
+            </a:pPr>
+            <a:r>
+              <a:rPr lang="en-IT" dirty="0"/>
+              <a:t>What fraction of the library is rRNA?</a:t>
+            </a:r>
+          </a:p>
+          <a:p>
+            <a:pPr marL="342900" lvl="0" indent="-342900">
+              <a:buFont typeface="Arial" panose="020B0604020202020204" pitchFamily="34" charset="0"/>
+              <a:buChar char="•"/>
+            </a:pPr>
+            <a:r>
+              <a:rPr lang="en-IT" dirty="0"/>
+              <a:t>Is it similar across replicates?</a:t>
+            </a:r>
+          </a:p>
+          <a:p>
+            <a:pPr marL="342900" lvl="0" indent="-342900">
+              <a:buFont typeface="Arial" panose="020B0604020202020204" pitchFamily="34" charset="0"/>
+              <a:buChar char="•"/>
+            </a:pPr>
+            <a:r>
+              <a:rPr lang="en-IT" dirty="0"/>
+              <a:t>Is one sample an outlier?</a:t>
+            </a:r>
+          </a:p>
+          <a:p>
+            <a:pPr marL="342900" lvl="0" indent="-342900">
+              <a:buFont typeface="Arial" panose="020B0604020202020204" pitchFamily="34" charset="0"/>
+              <a:buChar char="•"/>
+            </a:pPr>
+            <a:r>
+              <a:rPr lang="en-IT" dirty="0"/>
+              <a:t>Could differences reflect library preparation rather than biology?</a:t>
+            </a:r>
+          </a:p>
+        </p:txBody>
+      </p:sp>
+      <p:sp>
+        <p:nvSpPr>
+          <p:cNvPr id="12" name="TextBox 11">
+            <a:extLst>
+              <a:ext uri="{FF2B5EF4-FFF2-40B4-BE49-F238E27FC236}">
+                <a16:creationId xmlns:a16="http://schemas.microsoft.com/office/drawing/2014/main" id="{FD648F48-D08E-59C8-6573-83B97184173C}"/>
+              </a:ext>
+            </a:extLst>
+          </p:cNvPr>
+          <p:cNvSpPr txBox="1"/>
+          <p:nvPr/>
+        </p:nvSpPr>
+        <p:spPr>
+          <a:xfrm>
+            <a:off x="358285" y="4697156"/>
+            <a:ext cx="6737105" cy="1200329"/>
+          </a:xfrm>
+          <a:prstGeom prst="rect">
+            <a:avLst/>
+          </a:prstGeom>
+          <a:noFill/>
+          <a:ln>
+            <a:solidFill>
+              <a:schemeClr val="tx1"/>
+            </a:solidFill>
+          </a:ln>
+        </p:spPr>
+        <p:txBody>
+          <a:bodyPr wrap="square">
+            <a:spAutoFit/>
+          </a:bodyPr>
+          <a:lstStyle/>
+          <a:p>
+            <a:pPr>
+              <a:buNone/>
+            </a:pPr>
+            <a:r>
+              <a:rPr lang="en-IT" b="1" dirty="0">
+                <a:solidFill>
+                  <a:schemeClr val="accent4">
+                    <a:lumMod val="75000"/>
+                  </a:schemeClr>
+                </a:solidFill>
+              </a:rPr>
+              <a:t>Good practice</a:t>
+            </a:r>
+            <a:endParaRPr lang="en-IT" dirty="0">
+              <a:solidFill>
+                <a:schemeClr val="accent4">
+                  <a:lumMod val="75000"/>
+                </a:schemeClr>
+              </a:solidFill>
+            </a:endParaRPr>
+          </a:p>
+          <a:p>
+            <a:pPr>
+              <a:buNone/>
+            </a:pPr>
+            <a:r>
+              <a:rPr lang="en-IT" dirty="0"/>
+              <a:t>Use residual rRNA primarily as a </a:t>
+            </a:r>
+            <a:r>
+              <a:rPr lang="en-IT" b="1" dirty="0"/>
+              <a:t>library QC metric</a:t>
+            </a:r>
+            <a:r>
+              <a:rPr lang="en-IT" dirty="0"/>
+              <a:t>.</a:t>
+            </a:r>
+          </a:p>
+          <a:p>
+            <a:pPr>
+              <a:buNone/>
+            </a:pPr>
+            <a:r>
+              <a:rPr lang="en-IT" dirty="0"/>
+              <a:t>If contamination is substantial, the preferable solution is usually read-level classification/depletion:</a:t>
+            </a:r>
+          </a:p>
+        </p:txBody>
+      </p:sp>
+    </p:spTree>
+    <p:extLst>
+      <p:ext uri="{BB962C8B-B14F-4D97-AF65-F5344CB8AC3E}">
+        <p14:creationId xmlns:p14="http://schemas.microsoft.com/office/powerpoint/2010/main" val="2960519816"/>
+      </p:ext>
+    </p:extLst>
+  </p:cSld>
+  <p:clrMapOvr>
+    <a:masterClrMapping/>
+  </p:clrMapOvr>
+  <p:timing>
+    <p:tnLst>
+      <p:par>
+        <p:cTn id="1" dur="indefinite" restart="never" nodeType="tmRoot">
+          <p:childTnLst>
+            <p:seq concurrent="1" nextAc="seek">
+              <p:cTn id="2" dur="indefinite" nodeType="mainSeq">
+                <p:childTnLst>
+                  <p:par>
+                    <p:cTn id="3" fill="hold">
+                      <p:stCondLst>
+                        <p:cond delay="indefinite"/>
+                      </p:stCondLst>
+                      <p:childTnLst>
+                        <p:par>
+                          <p:cTn id="4" fill="hold">
+                            <p:stCondLst>
+                              <p:cond delay="0"/>
+                            </p:stCondLst>
+                            <p:childTnLst>
+                              <p:par>
+                                <p:cTn id="5" presetID="1" presetClass="entr" presetSubtype="0" fill="hold" grpId="0" nodeType="clickEffect">
+                                  <p:stCondLst>
+                                    <p:cond delay="0"/>
+                                  </p:stCondLst>
+                                  <p:childTnLst>
+                                    <p:set>
+                                      <p:cBhvr>
+                                        <p:cTn id="6" dur="1" fill="hold">
+                                          <p:stCondLst>
+                                            <p:cond delay="0"/>
+                                          </p:stCondLst>
+                                        </p:cTn>
+                                        <p:tgtEl>
+                                          <p:spTgt spid="8"/>
+                                        </p:tgtEl>
+                                        <p:attrNameLst>
+                                          <p:attrName>style.visibility</p:attrName>
+                                        </p:attrNameLst>
+                                      </p:cBhvr>
+                                      <p:to>
+                                        <p:strVal val="visible"/>
+                                      </p:to>
+                                    </p:set>
+                                  </p:childTnLst>
+                                </p:cTn>
+                              </p:par>
+                            </p:childTnLst>
+                          </p:cTn>
+                        </p:par>
+                      </p:childTnLst>
+                    </p:cTn>
+                  </p:par>
+                  <p:par>
+                    <p:cTn id="7" fill="hold">
+                      <p:stCondLst>
+                        <p:cond delay="indefinite"/>
+                      </p:stCondLst>
+                      <p:childTnLst>
+                        <p:par>
+                          <p:cTn id="8" fill="hold">
+                            <p:stCondLst>
+                              <p:cond delay="0"/>
+                            </p:stCondLst>
+                            <p:childTnLst>
+                              <p:par>
+                                <p:cTn id="9" presetID="1" presetClass="entr" presetSubtype="0" fill="hold" grpId="0" nodeType="clickEffect">
+                                  <p:stCondLst>
+                                    <p:cond delay="0"/>
+                                  </p:stCondLst>
+                                  <p:childTnLst>
+                                    <p:set>
+                                      <p:cBhvr>
+                                        <p:cTn id="10" dur="1" fill="hold">
+                                          <p:stCondLst>
+                                            <p:cond delay="0"/>
+                                          </p:stCondLst>
+                                        </p:cTn>
+                                        <p:tgtEl>
+                                          <p:spTgt spid="10"/>
+                                        </p:tgtEl>
+                                        <p:attrNameLst>
+                                          <p:attrName>style.visibility</p:attrName>
+                                        </p:attrNameLst>
+                                      </p:cBhvr>
+                                      <p:to>
+                                        <p:strVal val="visible"/>
+                                      </p:to>
+                                    </p:set>
+                                  </p:childTnLst>
+                                </p:cTn>
+                              </p:par>
+                              <p:par>
+                                <p:cTn id="11" presetID="1" presetClass="entr" presetSubtype="0" fill="hold" grpId="0" nodeType="withEffect">
+                                  <p:stCondLst>
+                                    <p:cond delay="0"/>
+                                  </p:stCondLst>
+                                  <p:childTnLst>
+                                    <p:set>
+                                      <p:cBhvr>
+                                        <p:cTn id="12" dur="1" fill="hold">
+                                          <p:stCondLst>
+                                            <p:cond delay="0"/>
+                                          </p:stCondLst>
+                                        </p:cTn>
+                                        <p:tgtEl>
+                                          <p:spTgt spid="12"/>
+                                        </p:tgtEl>
+                                        <p:attrNameLst>
+                                          <p:attrName>style.visibility</p:attrName>
+                                        </p:attrNameLst>
+                                      </p:cBhvr>
+                                      <p:to>
+                                        <p:strVal val="visible"/>
+                                      </p:to>
+                                    </p:set>
+                                  </p:childTnLst>
+                                </p:cTn>
+                              </p:par>
+                            </p:childTnLst>
+                          </p:cTn>
+                        </p:par>
+                      </p:childTnLst>
+                    </p:cTn>
+                  </p:par>
+                </p:childTnLst>
+              </p:cTn>
+              <p:prevCondLst>
+                <p:cond evt="onPrev" delay="0">
+                  <p:tgtEl>
+                    <p:sldTgt/>
+                  </p:tgtEl>
+                </p:cond>
+              </p:prevCondLst>
+              <p:nextCondLst>
+                <p:cond evt="onNext" delay="0">
+                  <p:tgtEl>
+                    <p:sldTgt/>
+                  </p:tgtEl>
+                </p:cond>
+              </p:nextCondLst>
+            </p:seq>
+          </p:childTnLst>
+        </p:cTn>
+      </p:par>
+    </p:tnLst>
+    <p:bldLst>
+      <p:bldP spid="8" grpId="0"/>
+      <p:bldP spid="10" grpId="0" animBg="1"/>
+      <p:bldP spid="12" grpId="0" animBg="1"/>
+    </p:bldLst>
+  </p:timing>
+</p:sld>
+</file>
+
+<file path=ppt/slides/slide9.xml><?xml version="1.0" encoding="utf-8"?>
+<p:sld xmlns:a="http://schemas.openxmlformats.org/drawingml/2006/main" xmlns:r="http://schemas.openxmlformats.org/officeDocument/2006/relationships" xmlns:p="http://schemas.openxmlformats.org/presentationml/2006/main">
+  <p:cSld>
+    <p:spTree>
+      <p:nvGrpSpPr>
+        <p:cNvPr id="1" name=""/>
+        <p:cNvGrpSpPr/>
+        <p:nvPr/>
+      </p:nvGrpSpPr>
+      <p:grpSpPr>
+        <a:xfrm>
+          <a:off x="0" y="0"/>
+          <a:ext cx="0" cy="0"/>
+          <a:chOff x="0" y="0"/>
+          <a:chExt cx="0" cy="0"/>
+        </a:xfrm>
+      </p:grpSpPr>
+      <p:sp>
+        <p:nvSpPr>
+          <p:cNvPr id="2" name="Title 1">
+            <a:extLst>
+              <a:ext uri="{FF2B5EF4-FFF2-40B4-BE49-F238E27FC236}">
+                <a16:creationId xmlns:a16="http://schemas.microsoft.com/office/drawing/2014/main" id="{2149AA4B-D605-2B6E-3F45-A9275793AE79}"/>
+              </a:ext>
+            </a:extLst>
+          </p:cNvPr>
+          <p:cNvSpPr>
+            <a:spLocks noGrp="1"/>
+          </p:cNvSpPr>
+          <p:nvPr>
+            <p:ph type="title"/>
+          </p:nvPr>
+        </p:nvSpPr>
+        <p:spPr/>
+        <p:txBody>
+          <a:bodyPr>
+            <a:normAutofit fontScale="90000"/>
+          </a:bodyPr>
+          <a:lstStyle/>
+          <a:p>
+            <a:r>
+              <a:rPr lang="en-IT" dirty="0"/>
+              <a:t>QC signals can be connected</a:t>
+            </a:r>
+            <a:endParaRPr lang="en-GB" dirty="0"/>
+          </a:p>
+        </p:txBody>
+      </p:sp>
+      <p:sp>
+        <p:nvSpPr>
+          <p:cNvPr id="3" name="Content Placeholder 2">
+            <a:extLst>
+              <a:ext uri="{FF2B5EF4-FFF2-40B4-BE49-F238E27FC236}">
+                <a16:creationId xmlns:a16="http://schemas.microsoft.com/office/drawing/2014/main" id="{7F6B9D4D-CF72-AD31-674D-710530A02A24}"/>
+              </a:ext>
+            </a:extLst>
+          </p:cNvPr>
+          <p:cNvSpPr>
+            <a:spLocks noGrp="1"/>
+          </p:cNvSpPr>
+          <p:nvPr>
+            <p:ph idx="1"/>
+          </p:nvPr>
+        </p:nvSpPr>
+        <p:spPr>
+          <a:xfrm>
+            <a:off x="134469" y="956049"/>
+            <a:ext cx="12057531" cy="3097205"/>
+          </a:xfrm>
+        </p:spPr>
+        <p:txBody>
+          <a:bodyPr>
+            <a:noAutofit/>
+          </a:bodyPr>
+          <a:lstStyle/>
+          <a:p>
+            <a:pPr marL="0" indent="0">
+              <a:buNone/>
+            </a:pPr>
+            <a:r>
+              <a:rPr lang="en-IT" sz="2000" b="1" dirty="0"/>
+              <a:t>	rRNA contamination, multi-mapping and apparent duplication can reinforce each other.</a:t>
+            </a:r>
+            <a:endParaRPr lang="en-IT" sz="2000" dirty="0"/>
+          </a:p>
+          <a:p>
+            <a:pPr marL="0" lvl="0" indent="0">
+              <a:buNone/>
+            </a:pPr>
+            <a:endParaRPr lang="en-IT" sz="2000" dirty="0"/>
+          </a:p>
+          <a:p>
+            <a:pPr marL="0" lvl="0" indent="0">
+              <a:buNone/>
+            </a:pPr>
+            <a:r>
+              <a:rPr lang="en-IT" sz="2000" dirty="0"/>
+              <a:t>	a) rRNA genes are often present in </a:t>
+            </a:r>
+            <a:r>
+              <a:rPr lang="en-IT" sz="2000" b="1" dirty="0"/>
+              <a:t>multiple highly similar copies</a:t>
+            </a:r>
+            <a:r>
+              <a:rPr lang="en-IT" sz="2000" dirty="0"/>
+              <a:t> in bacterial and higher Eukaryote 	genomes = </a:t>
+            </a:r>
+            <a:r>
+              <a:rPr lang="en-IT" sz="2000" b="1" dirty="0"/>
+              <a:t>multi-mapping</a:t>
+            </a:r>
+            <a:r>
+              <a:rPr lang="en-IT" sz="2000" dirty="0"/>
+              <a:t>.</a:t>
+            </a:r>
+          </a:p>
+          <a:p>
+            <a:pPr marL="0" indent="0">
+              <a:buNone/>
+            </a:pPr>
+            <a:r>
+              <a:rPr lang="en-IT" sz="2000" dirty="0"/>
+              <a:t>	 		</a:t>
+            </a:r>
+          </a:p>
+          <a:p>
+            <a:pPr marL="0" lvl="0" indent="0">
+              <a:buNone/>
+            </a:pPr>
+            <a:r>
+              <a:rPr lang="en-IT" sz="2000" dirty="0"/>
+              <a:t>	b) Because rRNA transcripts are highly abundant and relatively short/constrained genomic regions 	are sampled repeatedly, many fragments can have identical or similar coordinates </a:t>
+            </a:r>
+          </a:p>
+          <a:p>
+            <a:pPr marL="0" lvl="0" indent="0">
+              <a:buNone/>
+            </a:pPr>
+            <a:r>
+              <a:rPr lang="en-IT" sz="2000" b="1" dirty="0"/>
+              <a:t>	= coordinate duplication</a:t>
+            </a:r>
+            <a:r>
+              <a:rPr lang="en-IT" sz="2000" dirty="0"/>
+              <a:t>.</a:t>
+            </a:r>
+          </a:p>
+        </p:txBody>
+      </p:sp>
+      <p:sp>
+        <p:nvSpPr>
+          <p:cNvPr id="4" name="Date Placeholder 3">
+            <a:extLst>
+              <a:ext uri="{FF2B5EF4-FFF2-40B4-BE49-F238E27FC236}">
+                <a16:creationId xmlns:a16="http://schemas.microsoft.com/office/drawing/2014/main" id="{8044517F-9005-0335-13F9-811C76166B7C}"/>
+              </a:ext>
+            </a:extLst>
+          </p:cNvPr>
+          <p:cNvSpPr>
+            <a:spLocks noGrp="1"/>
+          </p:cNvSpPr>
+          <p:nvPr>
+            <p:ph type="dt" sz="half" idx="10"/>
+          </p:nvPr>
+        </p:nvSpPr>
+        <p:spPr/>
+        <p:txBody>
+          <a:bodyPr/>
+          <a:lstStyle/>
+          <a:p>
+            <a:fld id="{761DFEEA-1162-B343-ACBF-B3E92F6AC390}" type="datetime1">
+              <a:rPr lang="it-IT" smtClean="0"/>
+              <a:t>15/10/26</a:t>
+            </a:fld>
+            <a:endParaRPr lang="en-GB"/>
+          </a:p>
+        </p:txBody>
+      </p:sp>
+      <p:sp>
+        <p:nvSpPr>
+          <p:cNvPr id="5" name="Footer Placeholder 4">
+            <a:extLst>
+              <a:ext uri="{FF2B5EF4-FFF2-40B4-BE49-F238E27FC236}">
+                <a16:creationId xmlns:a16="http://schemas.microsoft.com/office/drawing/2014/main" id="{04AF9022-B3E6-0B8C-3E0A-252F46748E08}"/>
+              </a:ext>
+            </a:extLst>
+          </p:cNvPr>
+          <p:cNvSpPr>
+            <a:spLocks noGrp="1"/>
+          </p:cNvSpPr>
+          <p:nvPr>
+            <p:ph type="ftr" sz="quarter" idx="11"/>
+          </p:nvPr>
+        </p:nvSpPr>
+        <p:spPr/>
+        <p:txBody>
+          <a:bodyPr/>
+          <a:lstStyle/>
+          <a:p>
+            <a:r>
+              <a:rPr lang="en-GB"/>
+              <a:t>Day 1: Reproducible NGS Data Analysis on Personal Laptops</a:t>
+            </a:r>
+          </a:p>
+        </p:txBody>
+      </p:sp>
+      <p:sp>
+        <p:nvSpPr>
+          <p:cNvPr id="6" name="Slide Number Placeholder 5">
+            <a:extLst>
+              <a:ext uri="{FF2B5EF4-FFF2-40B4-BE49-F238E27FC236}">
+                <a16:creationId xmlns:a16="http://schemas.microsoft.com/office/drawing/2014/main" id="{B692864D-1A42-5094-7C0D-5ECE27F0F7F3}"/>
+              </a:ext>
+            </a:extLst>
+          </p:cNvPr>
+          <p:cNvSpPr>
+            <a:spLocks noGrp="1"/>
+          </p:cNvSpPr>
+          <p:nvPr>
+            <p:ph type="sldNum" sz="quarter" idx="12"/>
+          </p:nvPr>
+        </p:nvSpPr>
+        <p:spPr/>
+        <p:txBody>
+          <a:bodyPr/>
+          <a:lstStyle/>
+          <a:p>
+            <a:fld id="{62E92BA6-6E87-3343-8D2C-B7A656D628E4}" type="slidenum">
+              <a:rPr lang="en-GB" smtClean="0"/>
+              <a:t>8</a:t>
+            </a:fld>
+            <a:endParaRPr lang="en-GB"/>
+          </a:p>
+        </p:txBody>
+      </p:sp>
+      <p:sp>
+        <p:nvSpPr>
+          <p:cNvPr id="9" name="TextBox 8">
+            <a:extLst>
+              <a:ext uri="{FF2B5EF4-FFF2-40B4-BE49-F238E27FC236}">
+                <a16:creationId xmlns:a16="http://schemas.microsoft.com/office/drawing/2014/main" id="{402C23AB-3023-2226-FDF1-43F159C4E697}"/>
+              </a:ext>
+            </a:extLst>
+          </p:cNvPr>
+          <p:cNvSpPr txBox="1"/>
+          <p:nvPr/>
+        </p:nvSpPr>
+        <p:spPr>
+          <a:xfrm>
+            <a:off x="134470" y="4460824"/>
+            <a:ext cx="7593968" cy="369332"/>
+          </a:xfrm>
+          <a:prstGeom prst="rect">
+            <a:avLst/>
+          </a:prstGeom>
+          <a:noFill/>
+        </p:spPr>
+        <p:txBody>
+          <a:bodyPr wrap="square">
+            <a:spAutoFit/>
+          </a:bodyPr>
+          <a:lstStyle/>
+          <a:p>
+            <a:r>
+              <a:rPr lang="en-IT" b="1" dirty="0"/>
+              <a:t>Do these QC measurements tell a coherent story about the library?</a:t>
+            </a:r>
+            <a:endParaRPr lang="en-GB" b="1" dirty="0"/>
+          </a:p>
+        </p:txBody>
+      </p:sp>
+      <p:sp>
+        <p:nvSpPr>
+          <p:cNvPr id="11" name="TextBox 10">
+            <a:extLst>
+              <a:ext uri="{FF2B5EF4-FFF2-40B4-BE49-F238E27FC236}">
+                <a16:creationId xmlns:a16="http://schemas.microsoft.com/office/drawing/2014/main" id="{B403F245-032B-31B6-9B84-9691C3A272E4}"/>
+              </a:ext>
+            </a:extLst>
+          </p:cNvPr>
+          <p:cNvSpPr txBox="1"/>
+          <p:nvPr/>
+        </p:nvSpPr>
+        <p:spPr>
+          <a:xfrm>
+            <a:off x="134470" y="5000333"/>
+            <a:ext cx="11834446" cy="646331"/>
+          </a:xfrm>
+          <a:prstGeom prst="rect">
+            <a:avLst/>
+          </a:prstGeom>
+          <a:noFill/>
+        </p:spPr>
+        <p:txBody>
+          <a:bodyPr wrap="square">
+            <a:spAutoFit/>
+          </a:bodyPr>
+          <a:lstStyle/>
+          <a:p>
+            <a:pPr>
+              <a:buNone/>
+            </a:pPr>
+            <a:r>
+              <a:rPr lang="en-IT" dirty="0"/>
+              <a:t>For example, </a:t>
+            </a:r>
+            <a:r>
+              <a:rPr lang="en-IT" b="1" dirty="0"/>
+              <a:t>high rRNA + high multimapping + high duplication</a:t>
+            </a:r>
+            <a:r>
+              <a:rPr lang="en-IT" dirty="0"/>
+              <a:t> strongly suggests inspecting the rRNA-derived reads before concluding that the entire RNA-seq library has poor complexity.</a:t>
+            </a:r>
+          </a:p>
+        </p:txBody>
+      </p:sp>
+    </p:spTree>
+    <p:extLst>
+      <p:ext uri="{BB962C8B-B14F-4D97-AF65-F5344CB8AC3E}">
+        <p14:creationId xmlns:p14="http://schemas.microsoft.com/office/powerpoint/2010/main" val="3599874629"/>
+      </p:ext>
+    </p:extLst>
+  </p:cSld>
+  <p:clrMapOvr>
+    <a:masterClrMapping/>
+  </p:clrMapOvr>
+  <p:timing>
+    <p:tnLst>
+      <p:par>
+        <p:cTn id="1" dur="indefinite" restart="never" nodeType="tmRoot">
+          <p:childTnLst>
+            <p:seq concurrent="1" nextAc="seek">
+              <p:cTn id="2" dur="indefinite" nodeType="mainSeq">
+                <p:childTnLst>
+                  <p:par>
+                    <p:cTn id="3" fill="hold">
+                      <p:stCondLst>
+                        <p:cond delay="indefinite"/>
+                      </p:stCondLst>
+                      <p:childTnLst>
+                        <p:par>
+                          <p:cTn id="4" fill="hold">
+                            <p:stCondLst>
+                              <p:cond delay="0"/>
+                            </p:stCondLst>
+                            <p:childTnLst>
+                              <p:par>
+                                <p:cTn id="5" presetID="1" presetClass="entr" presetSubtype="0" fill="hold" grpId="0" nodeType="clickEffect">
+                                  <p:stCondLst>
+                                    <p:cond delay="0"/>
+                                  </p:stCondLst>
+                                  <p:childTnLst>
+                                    <p:set>
+                                      <p:cBhvr>
+                                        <p:cTn id="6" dur="1" fill="hold">
+                                          <p:stCondLst>
+                                            <p:cond delay="0"/>
+                                          </p:stCondLst>
+                                        </p:cTn>
+                                        <p:tgtEl>
+                                          <p:spTgt spid="11"/>
+                                        </p:tgtEl>
+                                        <p:attrNameLst>
+                                          <p:attrName>style.visibility</p:attrName>
+                                        </p:attrNameLst>
+                                      </p:cBhvr>
+                                      <p:to>
+                                        <p:strVal val="visible"/>
+                                      </p:to>
+                                    </p:set>
+                                  </p:childTnLst>
+                                </p:cTn>
+                              </p:par>
+                              <p:par>
+                                <p:cTn id="7" presetID="1" presetClass="entr" presetSubtype="0" fill="hold" grpId="0" nodeType="withEffect">
+                                  <p:stCondLst>
+                                    <p:cond delay="0"/>
+                                  </p:stCondLst>
+                                  <p:childTnLst>
+                                    <p:set>
+                                      <p:cBhvr>
+                                        <p:cTn id="8" dur="1" fill="hold">
+                                          <p:stCondLst>
+                                            <p:cond delay="0"/>
+                                          </p:stCondLst>
+                                        </p:cTn>
+                                        <p:tgtEl>
+                                          <p:spTgt spid="9"/>
+                                        </p:tgtEl>
+                                        <p:attrNameLst>
+                                          <p:attrName>style.visibility</p:attrName>
+                                        </p:attrNameLst>
+                                      </p:cBhvr>
+                                      <p:to>
+                                        <p:strVal val="visible"/>
+                                      </p:to>
+                                    </p:set>
+                                  </p:childTnLst>
+                                </p:cTn>
+                              </p:par>
+                            </p:childTnLst>
+                          </p:cTn>
+                        </p:par>
+                      </p:childTnLst>
+                    </p:cTn>
+                  </p:par>
+                </p:childTnLst>
+              </p:cTn>
+              <p:prevCondLst>
+                <p:cond evt="onPrev" delay="0">
+                  <p:tgtEl>
+                    <p:sldTgt/>
+                  </p:tgtEl>
+                </p:cond>
+              </p:prevCondLst>
+              <p:nextCondLst>
+                <p:cond evt="onNext" delay="0">
+                  <p:tgtEl>
+                    <p:sldTgt/>
+                  </p:tgtEl>
+                </p:cond>
+              </p:nextCondLst>
+            </p:seq>
+          </p:childTnLst>
+        </p:cTn>
+      </p:par>
+    </p:tnLst>
+    <p:bldLst>
+      <p:bldP spid="9" grpId="0"/>
+      <p:bldP spid="11" grpId="0"/>
+    </p:bldLst>
+  </p:timing>
 </p:sld>
 </file>
 

</xml_diff>